<commit_message>
A1 poster template: stronger layout + how-to-write guidance
Improve the NLCS 2027 poster (594x841 mm) for poster best practice and make the
placeholders teach good abstract writing:
- Add a full-width 'Take-home message' strip under the header (the one line a
  passer-by should remember).
- Red rule under each section heading; results figures enlarged to dominate.
- Replace bracket placeholders with concise guidance on how to write each
  section well (Background: problem/why/how common + gap; Aim: one specific
  question; Methods: design/data/analysis, enough to judge validity; Results:
  lead with the result, numbers with 95% CI; Conclusions: meaning + one
  limitation + implication, don't overclaim; plus a 'Key numbers' note).
- Results-forward title prompt; underline-the-presenter author note.

Generated via brand-carousel/pptx/build.js (local, gitignored). Review in
PowerPoint — no LibreOffice here to render.

Co-Authored-By: Claude Opus 4.8 <noreply@anthropic.com>
</commit_message>
<xml_diff>
--- a/ntog2027/nlcs2027-poster-A1-template.pptx
+++ b/ntog2027/nlcs2027-poster-A1-template.pptx
@@ -970,8 +970,8 @@
         </p:nvSpPr>
         <p:spPr>
           <a:xfrm>
-            <a:off x="3931920" y="1371600"/>
-            <a:ext cx="16642080" cy="1554480"/>
+            <a:off x="3931920" y="1325880"/>
+            <a:ext cx="16642080" cy="1645920"/>
           </a:xfrm>
           <a:prstGeom prst="rect">
             <a:avLst/>
@@ -987,7 +987,7 @@
               <a:buNone/>
             </a:pPr>
             <a:r>
-              <a:rPr lang="en-US" sz="4000" b="1" dirty="0">
+              <a:rPr lang="en-US" sz="4400" b="1" dirty="0">
                 <a:solidFill>
                   <a:srgbClr val="FFFFFF"/>
                 </a:solidFill>
@@ -995,9 +995,9 @@
                 <a:ea typeface="Montserrat" pitchFamily="34" charset="-122"/>
                 <a:cs typeface="Montserrat" pitchFamily="34" charset="-120"/>
               </a:rPr>
-              <a:t>[ Poster title goes here — keep it short and specific ]</a:t>
-            </a:r>
-            <a:endParaRPr lang="en-US" sz="4000" dirty="0"/>
+              <a:t>Your poster title — short, specific, and results-forward</a:t>
+            </a:r>
+            <a:endParaRPr lang="en-US" sz="4400" dirty="0"/>
           </a:p>
         </p:txBody>
       </p:sp>
@@ -1009,7 +1009,7 @@
         </p:nvSpPr>
         <p:spPr>
           <a:xfrm>
-            <a:off x="3931920" y="3063240"/>
+            <a:off x="3931920" y="3108960"/>
             <a:ext cx="16642080" cy="457200"/>
           </a:xfrm>
           <a:prstGeom prst="rect">
@@ -1034,7 +1034,7 @@
                 <a:ea typeface="Open Sans" pitchFamily="34" charset="-122"/>
                 <a:cs typeface="Open Sans" pitchFamily="34" charset="-120"/>
               </a:rPr>
-              <a:t>[ Author A¹, Author B², Author C¹ ]</a:t>
+              <a:t>Author A¹, Author B², Author C¹   (underline the presenting author)</a:t>
             </a:r>
             <a:endParaRPr lang="en-US" sz="2200" dirty="0"/>
           </a:p>
@@ -1048,7 +1048,7 @@
         </p:nvSpPr>
         <p:spPr>
           <a:xfrm>
-            <a:off x="3931920" y="3611880"/>
+            <a:off x="3931920" y="3657600"/>
             <a:ext cx="16642080" cy="457200"/>
           </a:xfrm>
           <a:prstGeom prst="rect">
@@ -1073,7 +1073,7 @@
                 <a:ea typeface="Open Sans" pitchFamily="34" charset="-122"/>
                 <a:cs typeface="Open Sans" pitchFamily="34" charset="-120"/>
               </a:rPr>
-              <a:t>[ ¹ Affiliation, City, Country · ² Affiliation, City, Country ]</a:t>
+              <a:t>¹ Affiliation, City, Country   ·   ² Affiliation, City, Country</a:t>
             </a:r>
             <a:endParaRPr lang="en-US" sz="1600" dirty="0"/>
           </a:p>
@@ -1081,57 +1081,18 @@
       </p:sp>
       <p:sp>
         <p:nvSpPr>
-          <p:cNvPr id="8" name="Text 4"/>
-          <p:cNvSpPr/>
-          <p:nvPr/>
-        </p:nvSpPr>
-        <p:spPr>
-          <a:xfrm>
-            <a:off x="822960" y="4937760"/>
-            <a:ext cx="6400800" cy="548640"/>
-          </a:xfrm>
-          <a:prstGeom prst="rect">
-            <a:avLst/>
-          </a:prstGeom>
-          <a:noFill/>
-          <a:ln/>
-        </p:spPr>
-        <p:txBody>
-          <a:bodyPr wrap="square" rtlCol="0" anchor="ctr"/>
-          <a:lstStyle/>
-          <a:p>
-            <a:pPr indent="0" marL="0">
-              <a:buNone/>
-            </a:pPr>
-            <a:r>
-              <a:rPr lang="en-US" sz="3000" b="1" dirty="0">
-                <a:solidFill>
-                  <a:srgbClr val="74101F"/>
-                </a:solidFill>
-                <a:latin typeface="Montserrat" pitchFamily="34" charset="0"/>
-                <a:ea typeface="Montserrat" pitchFamily="34" charset="-122"/>
-                <a:cs typeface="Montserrat" pitchFamily="34" charset="-120"/>
-              </a:rPr>
-              <a:t>Background</a:t>
-            </a:r>
-            <a:endParaRPr lang="en-US" sz="3000" dirty="0"/>
-          </a:p>
-        </p:txBody>
-      </p:sp>
-      <p:sp>
-        <p:nvSpPr>
-          <p:cNvPr id="9" name="Shape 5"/>
-          <p:cNvSpPr/>
-          <p:nvPr/>
-        </p:nvSpPr>
-        <p:spPr>
-          <a:xfrm>
-            <a:off x="822960" y="5623560"/>
-            <a:ext cx="6400800" cy="4023360"/>
+          <p:cNvPr id="8" name="Shape 4"/>
+          <p:cNvSpPr/>
+          <p:nvPr/>
+        </p:nvSpPr>
+        <p:spPr>
+          <a:xfrm>
+            <a:off x="822960" y="4709160"/>
+            <a:ext cx="19741896" cy="1783080"/>
           </a:xfrm>
           <a:prstGeom prst="roundRect">
             <a:avLst>
-              <a:gd name="adj" fmla="val 1136"/>
+              <a:gd name="adj" fmla="val 3077"/>
             </a:avLst>
           </a:prstGeom>
           <a:solidFill>
@@ -1147,14 +1108,73 @@
       </p:sp>
       <p:sp>
         <p:nvSpPr>
+          <p:cNvPr id="9" name="Shape 5"/>
+          <p:cNvSpPr/>
+          <p:nvPr/>
+        </p:nvSpPr>
+        <p:spPr>
+          <a:xfrm>
+            <a:off x="822960" y="4709160"/>
+            <a:ext cx="164592" cy="1783080"/>
+          </a:xfrm>
+          <a:prstGeom prst="rect">
+            <a:avLst/>
+          </a:prstGeom>
+          <a:solidFill>
+            <a:srgbClr val="C8102E"/>
+          </a:solidFill>
+          <a:ln/>
+        </p:spPr>
+      </p:sp>
+      <p:sp>
+        <p:nvSpPr>
           <p:cNvPr id="10" name="Text 6"/>
           <p:cNvSpPr/>
           <p:nvPr/>
         </p:nvSpPr>
         <p:spPr>
           <a:xfrm>
-            <a:off x="1143000" y="5897880"/>
-            <a:ext cx="5760720" cy="3474720"/>
+            <a:off x="1325880" y="4882896"/>
+            <a:ext cx="18836640" cy="457200"/>
+          </a:xfrm>
+          <a:prstGeom prst="rect">
+            <a:avLst/>
+          </a:prstGeom>
+          <a:noFill/>
+          <a:ln/>
+        </p:spPr>
+        <p:txBody>
+          <a:bodyPr wrap="square" rtlCol="0" anchor="ctr"/>
+          <a:lstStyle/>
+          <a:p>
+            <a:pPr indent="0" marL="0">
+              <a:buNone/>
+            </a:pPr>
+            <a:r>
+              <a:rPr lang="en-US" sz="2000" b="1" spc="100" kern="0" dirty="0">
+                <a:solidFill>
+                  <a:srgbClr val="74101F"/>
+                </a:solidFill>
+                <a:latin typeface="Montserrat" pitchFamily="34" charset="0"/>
+                <a:ea typeface="Montserrat" pitchFamily="34" charset="-122"/>
+                <a:cs typeface="Montserrat" pitchFamily="34" charset="-120"/>
+              </a:rPr>
+              <a:t>TAKE-HOME MESSAGE</a:t>
+            </a:r>
+            <a:endParaRPr lang="en-US" sz="2000" dirty="0"/>
+          </a:p>
+        </p:txBody>
+      </p:sp>
+      <p:sp>
+        <p:nvSpPr>
+          <p:cNvPr id="11" name="Text 7"/>
+          <p:cNvSpPr/>
+          <p:nvPr/>
+        </p:nvSpPr>
+        <p:spPr>
+          <a:xfrm>
+            <a:off x="1325880" y="5340096"/>
+            <a:ext cx="18836640" cy="1005840"/>
           </a:xfrm>
           <a:prstGeom prst="rect">
             <a:avLst/>
@@ -1167,36 +1187,33 @@
           <a:lstStyle/>
           <a:p>
             <a:pPr indent="0" marL="0">
-              <a:lnSpc>
-                <a:spcPct val="130000"/>
-              </a:lnSpc>
               <a:buNone/>
             </a:pPr>
             <a:r>
-              <a:rPr lang="en-US" sz="2200" dirty="0">
-                <a:solidFill>
-                  <a:srgbClr val="252525"/>
+              <a:rPr lang="en-US" sz="2400" i="1" dirty="0">
+                <a:solidFill>
+                  <a:srgbClr val="52606D"/>
                 </a:solidFill>
                 <a:latin typeface="Open Sans" pitchFamily="34" charset="0"/>
                 <a:ea typeface="Open Sans" pitchFamily="34" charset="-122"/>
                 <a:cs typeface="Open Sans" pitchFamily="34" charset="-120"/>
               </a:rPr>
-              <a:t>[ Clinical problem; why it matters; how common in the Nordic setting. ]</a:t>
-            </a:r>
-            <a:endParaRPr lang="en-US" sz="2200" dirty="0"/>
-          </a:p>
-        </p:txBody>
-      </p:sp>
-      <p:sp>
-        <p:nvSpPr>
-          <p:cNvPr id="11" name="Text 7"/>
-          <p:cNvSpPr/>
-          <p:nvPr/>
-        </p:nvSpPr>
-        <p:spPr>
-          <a:xfrm>
-            <a:off x="822960" y="10287000"/>
-            <a:ext cx="6400800" cy="548640"/>
+              <a:t>The one sentence a passer-by should remember — your single most important, specific finding.</a:t>
+            </a:r>
+            <a:endParaRPr lang="en-US" sz="2400" dirty="0"/>
+          </a:p>
+        </p:txBody>
+      </p:sp>
+      <p:sp>
+        <p:nvSpPr>
+          <p:cNvPr id="12" name="Text 8"/>
+          <p:cNvSpPr/>
+          <p:nvPr/>
+        </p:nvSpPr>
+        <p:spPr>
+          <a:xfrm>
+            <a:off x="822960" y="6903720"/>
+            <a:ext cx="6400800" cy="502920"/>
           </a:xfrm>
           <a:prstGeom prst="rect">
             <a:avLst/>
@@ -1220,7 +1237,7 @@
                 <a:ea typeface="Montserrat" pitchFamily="34" charset="-122"/>
                 <a:cs typeface="Montserrat" pitchFamily="34" charset="-120"/>
               </a:rPr>
-              <a:t>Aim</a:t>
+              <a:t>Background</a:t>
             </a:r>
             <a:endParaRPr lang="en-US" sz="3000" dirty="0"/>
           </a:p>
@@ -1228,18 +1245,41 @@
       </p:sp>
       <p:sp>
         <p:nvSpPr>
-          <p:cNvPr id="12" name="Shape 8"/>
-          <p:cNvSpPr/>
-          <p:nvPr/>
-        </p:nvSpPr>
-        <p:spPr>
-          <a:xfrm>
-            <a:off x="822960" y="10972800"/>
-            <a:ext cx="6400800" cy="2377440"/>
+          <p:cNvPr id="13" name="Shape 9"/>
+          <p:cNvSpPr/>
+          <p:nvPr/>
+        </p:nvSpPr>
+        <p:spPr>
+          <a:xfrm>
+            <a:off x="822960" y="7488936"/>
+            <a:ext cx="2011680" cy="0"/>
+          </a:xfrm>
+          <a:prstGeom prst="line">
+            <a:avLst/>
+          </a:prstGeom>
+          <a:noFill/>
+          <a:ln w="38100">
+            <a:solidFill>
+              <a:srgbClr val="C8102E"/>
+            </a:solidFill>
+            <a:prstDash val="solid"/>
+          </a:ln>
+        </p:spPr>
+      </p:sp>
+      <p:sp>
+        <p:nvSpPr>
+          <p:cNvPr id="14" name="Shape 10"/>
+          <p:cNvSpPr/>
+          <p:nvPr/>
+        </p:nvSpPr>
+        <p:spPr>
+          <a:xfrm>
+            <a:off x="822960" y="7653528"/>
+            <a:ext cx="6400800" cy="4389120"/>
           </a:xfrm>
           <a:prstGeom prst="roundRect">
             <a:avLst>
-              <a:gd name="adj" fmla="val 1923"/>
+              <a:gd name="adj" fmla="val 1042"/>
             </a:avLst>
           </a:prstGeom>
           <a:solidFill>
@@ -1255,14 +1295,14 @@
       </p:sp>
       <p:sp>
         <p:nvSpPr>
-          <p:cNvPr id="13" name="Text 9"/>
-          <p:cNvSpPr/>
-          <p:nvPr/>
-        </p:nvSpPr>
-        <p:spPr>
-          <a:xfrm>
-            <a:off x="1143000" y="11247120"/>
-            <a:ext cx="5760720" cy="1828800"/>
+          <p:cNvPr id="15" name="Text 11"/>
+          <p:cNvSpPr/>
+          <p:nvPr/>
+        </p:nvSpPr>
+        <p:spPr>
+          <a:xfrm>
+            <a:off x="1188720" y="7909560"/>
+            <a:ext cx="5669280" cy="3886200"/>
           </a:xfrm>
           <a:prstGeom prst="rect">
             <a:avLst/>
@@ -1281,15 +1321,15 @@
               <a:buNone/>
             </a:pPr>
             <a:r>
-              <a:rPr lang="en-US" sz="2200" dirty="0">
-                <a:solidFill>
-                  <a:srgbClr val="252525"/>
+              <a:rPr lang="en-US" sz="2200" i="1" dirty="0">
+                <a:solidFill>
+                  <a:srgbClr val="52606D"/>
                 </a:solidFill>
                 <a:latin typeface="Open Sans" pitchFamily="34" charset="0"/>
                 <a:ea typeface="Open Sans" pitchFamily="34" charset="-122"/>
                 <a:cs typeface="Open Sans" pitchFamily="34" charset="-120"/>
               </a:rPr>
-              <a:t>[ The single question this study set out to answer. ]</a:t>
+              <a:t>1–2 sentences: the clinical problem, why it matters, and how common it is — then the gap your study fills.</a:t>
             </a:r>
             <a:endParaRPr lang="en-US" sz="2200" dirty="0"/>
           </a:p>
@@ -1297,14 +1337,14 @@
       </p:sp>
       <p:sp>
         <p:nvSpPr>
-          <p:cNvPr id="14" name="Text 10"/>
-          <p:cNvSpPr/>
-          <p:nvPr/>
-        </p:nvSpPr>
-        <p:spPr>
-          <a:xfrm>
-            <a:off x="822960" y="13990320"/>
-            <a:ext cx="6400800" cy="548640"/>
+          <p:cNvPr id="16" name="Text 12"/>
+          <p:cNvSpPr/>
+          <p:nvPr/>
+        </p:nvSpPr>
+        <p:spPr>
+          <a:xfrm>
+            <a:off x="822960" y="12591288"/>
+            <a:ext cx="6400800" cy="502920"/>
           </a:xfrm>
           <a:prstGeom prst="rect">
             <a:avLst/>
@@ -1328,7 +1368,7 @@
                 <a:ea typeface="Montserrat" pitchFamily="34" charset="-122"/>
                 <a:cs typeface="Montserrat" pitchFamily="34" charset="-120"/>
               </a:rPr>
-              <a:t>Methods</a:t>
+              <a:t>Aim</a:t>
             </a:r>
             <a:endParaRPr lang="en-US" sz="3000" dirty="0"/>
           </a:p>
@@ -1336,18 +1376,41 @@
       </p:sp>
       <p:sp>
         <p:nvSpPr>
-          <p:cNvPr id="15" name="Shape 11"/>
-          <p:cNvSpPr/>
-          <p:nvPr/>
-        </p:nvSpPr>
-        <p:spPr>
-          <a:xfrm>
-            <a:off x="822960" y="14676120"/>
-            <a:ext cx="6400800" cy="5486400"/>
+          <p:cNvPr id="17" name="Shape 13"/>
+          <p:cNvSpPr/>
+          <p:nvPr/>
+        </p:nvSpPr>
+        <p:spPr>
+          <a:xfrm>
+            <a:off x="822960" y="13176504"/>
+            <a:ext cx="2011680" cy="0"/>
+          </a:xfrm>
+          <a:prstGeom prst="line">
+            <a:avLst/>
+          </a:prstGeom>
+          <a:noFill/>
+          <a:ln w="38100">
+            <a:solidFill>
+              <a:srgbClr val="C8102E"/>
+            </a:solidFill>
+            <a:prstDash val="solid"/>
+          </a:ln>
+        </p:spPr>
+      </p:sp>
+      <p:sp>
+        <p:nvSpPr>
+          <p:cNvPr id="18" name="Shape 14"/>
+          <p:cNvSpPr/>
+          <p:nvPr/>
+        </p:nvSpPr>
+        <p:spPr>
+          <a:xfrm>
+            <a:off x="822960" y="13341096"/>
+            <a:ext cx="6400800" cy="2560320"/>
           </a:xfrm>
           <a:prstGeom prst="roundRect">
             <a:avLst>
-              <a:gd name="adj" fmla="val 833"/>
+              <a:gd name="adj" fmla="val 1786"/>
             </a:avLst>
           </a:prstGeom>
           <a:solidFill>
@@ -1363,14 +1426,145 @@
       </p:sp>
       <p:sp>
         <p:nvSpPr>
-          <p:cNvPr id="16" name="Text 12"/>
-          <p:cNvSpPr/>
-          <p:nvPr/>
-        </p:nvSpPr>
-        <p:spPr>
-          <a:xfrm>
-            <a:off x="1143000" y="14950440"/>
-            <a:ext cx="5760720" cy="4937760"/>
+          <p:cNvPr id="19" name="Text 15"/>
+          <p:cNvSpPr/>
+          <p:nvPr/>
+        </p:nvSpPr>
+        <p:spPr>
+          <a:xfrm>
+            <a:off x="1188720" y="13597128"/>
+            <a:ext cx="5669280" cy="2057400"/>
+          </a:xfrm>
+          <a:prstGeom prst="rect">
+            <a:avLst/>
+          </a:prstGeom>
+          <a:noFill/>
+          <a:ln/>
+        </p:spPr>
+        <p:txBody>
+          <a:bodyPr wrap="square" rtlCol="0" anchor="t"/>
+          <a:lstStyle/>
+          <a:p>
+            <a:pPr indent="0" marL="0">
+              <a:lnSpc>
+                <a:spcPct val="130000"/>
+              </a:lnSpc>
+              <a:buNone/>
+            </a:pPr>
+            <a:r>
+              <a:rPr lang="en-US" sz="2200" i="1" dirty="0">
+                <a:solidFill>
+                  <a:srgbClr val="52606D"/>
+                </a:solidFill>
+                <a:latin typeface="Open Sans" pitchFamily="34" charset="0"/>
+                <a:ea typeface="Open Sans" pitchFamily="34" charset="-122"/>
+                <a:cs typeface="Open Sans" pitchFamily="34" charset="-120"/>
+              </a:rPr>
+              <a:t>One sentence: the single, specific, answerable question or objective.</a:t>
+            </a:r>
+            <a:endParaRPr lang="en-US" sz="2200" dirty="0"/>
+          </a:p>
+        </p:txBody>
+      </p:sp>
+      <p:sp>
+        <p:nvSpPr>
+          <p:cNvPr id="20" name="Text 16"/>
+          <p:cNvSpPr/>
+          <p:nvPr/>
+        </p:nvSpPr>
+        <p:spPr>
+          <a:xfrm>
+            <a:off x="822960" y="16450056"/>
+            <a:ext cx="6400800" cy="502920"/>
+          </a:xfrm>
+          <a:prstGeom prst="rect">
+            <a:avLst/>
+          </a:prstGeom>
+          <a:noFill/>
+          <a:ln/>
+        </p:spPr>
+        <p:txBody>
+          <a:bodyPr wrap="square" rtlCol="0" anchor="ctr"/>
+          <a:lstStyle/>
+          <a:p>
+            <a:pPr indent="0" marL="0">
+              <a:buNone/>
+            </a:pPr>
+            <a:r>
+              <a:rPr lang="en-US" sz="3000" b="1" dirty="0">
+                <a:solidFill>
+                  <a:srgbClr val="74101F"/>
+                </a:solidFill>
+                <a:latin typeface="Montserrat" pitchFamily="34" charset="0"/>
+                <a:ea typeface="Montserrat" pitchFamily="34" charset="-122"/>
+                <a:cs typeface="Montserrat" pitchFamily="34" charset="-120"/>
+              </a:rPr>
+              <a:t>Methods</a:t>
+            </a:r>
+            <a:endParaRPr lang="en-US" sz="3000" dirty="0"/>
+          </a:p>
+        </p:txBody>
+      </p:sp>
+      <p:sp>
+        <p:nvSpPr>
+          <p:cNvPr id="21" name="Shape 17"/>
+          <p:cNvSpPr/>
+          <p:nvPr/>
+        </p:nvSpPr>
+        <p:spPr>
+          <a:xfrm>
+            <a:off x="822960" y="17035272"/>
+            <a:ext cx="2011680" cy="0"/>
+          </a:xfrm>
+          <a:prstGeom prst="line">
+            <a:avLst/>
+          </a:prstGeom>
+          <a:noFill/>
+          <a:ln w="38100">
+            <a:solidFill>
+              <a:srgbClr val="C8102E"/>
+            </a:solidFill>
+            <a:prstDash val="solid"/>
+          </a:ln>
+        </p:spPr>
+      </p:sp>
+      <p:sp>
+        <p:nvSpPr>
+          <p:cNvPr id="22" name="Shape 18"/>
+          <p:cNvSpPr/>
+          <p:nvPr/>
+        </p:nvSpPr>
+        <p:spPr>
+          <a:xfrm>
+            <a:off x="822960" y="17199864"/>
+            <a:ext cx="6400800" cy="7863840"/>
+          </a:xfrm>
+          <a:prstGeom prst="roundRect">
+            <a:avLst>
+              <a:gd name="adj" fmla="val 714"/>
+            </a:avLst>
+          </a:prstGeom>
+          <a:solidFill>
+            <a:srgbClr val="FFF1F3"/>
+          </a:solidFill>
+          <a:ln w="12700">
+            <a:solidFill>
+              <a:srgbClr val="F2B8C2"/>
+            </a:solidFill>
+            <a:prstDash val="solid"/>
+          </a:ln>
+        </p:spPr>
+      </p:sp>
+      <p:sp>
+        <p:nvSpPr>
+          <p:cNvPr id="23" name="Text 19"/>
+          <p:cNvSpPr/>
+          <p:nvPr/>
+        </p:nvSpPr>
+        <p:spPr>
+          <a:xfrm>
+            <a:off x="1188720" y="17455896"/>
+            <a:ext cx="5669280" cy="7360920"/>
           </a:xfrm>
           <a:prstGeom prst="rect">
             <a:avLst/>
@@ -1398,7 +1592,7 @@
                 <a:ea typeface="Open Sans" pitchFamily="34" charset="-122"/>
                 <a:cs typeface="Open Sans" pitchFamily="34" charset="-120"/>
               </a:rPr>
-              <a:t>[ Design, setting, population. ]</a:t>
+              <a:t>Design, setting and population.</a:t>
             </a:r>
             <a:endParaRPr lang="en-US" sz="2200" dirty="0"/>
           </a:p>
@@ -1419,7 +1613,7 @@
                 <a:ea typeface="Open Sans" pitchFamily="34" charset="-122"/>
                 <a:cs typeface="Open Sans" pitchFamily="34" charset="-120"/>
               </a:rPr>
-              <a:t>[ Data sources / measurements. ]</a:t>
+              <a:t>Data sources and key measurements.</a:t>
             </a:r>
             <a:endParaRPr lang="en-US" sz="2200" dirty="0"/>
           </a:p>
@@ -1440,22 +1634,43 @@
                 <a:ea typeface="Open Sans" pitchFamily="34" charset="-122"/>
                 <a:cs typeface="Open Sans" pitchFamily="34" charset="-120"/>
               </a:rPr>
-              <a:t>[ Analysis. ]</a:t>
+              <a:t>Analysis — and how bias / confounding were handled.</a:t>
             </a:r>
             <a:endParaRPr lang="en-US" sz="2200" dirty="0"/>
           </a:p>
-        </p:txBody>
-      </p:sp>
-      <p:sp>
-        <p:nvSpPr>
-          <p:cNvPr id="17" name="Text 13"/>
-          <p:cNvSpPr/>
-          <p:nvPr/>
-        </p:nvSpPr>
-        <p:spPr>
-          <a:xfrm>
-            <a:off x="7772400" y="4937760"/>
-            <a:ext cx="6400800" cy="548640"/>
+          <a:p>
+            <a:pPr marL="342900" indent="-342900">
+              <a:lnSpc>
+                <a:spcPct val="130000"/>
+              </a:lnSpc>
+              <a:buSzPct val="100000"/>
+              <a:buChar char="•"/>
+            </a:pPr>
+            <a:r>
+              <a:rPr lang="en-US" sz="2200" dirty="0">
+                <a:solidFill>
+                  <a:srgbClr val="252525"/>
+                </a:solidFill>
+                <a:latin typeface="Open Sans" pitchFamily="34" charset="0"/>
+                <a:ea typeface="Open Sans" pitchFamily="34" charset="-122"/>
+                <a:cs typeface="Open Sans" pitchFamily="34" charset="-120"/>
+              </a:rPr>
+              <a:t>Just enough detail to judge validity.</a:t>
+            </a:r>
+            <a:endParaRPr lang="en-US" sz="2200" dirty="0"/>
+          </a:p>
+        </p:txBody>
+      </p:sp>
+      <p:sp>
+        <p:nvSpPr>
+          <p:cNvPr id="24" name="Text 20"/>
+          <p:cNvSpPr/>
+          <p:nvPr/>
+        </p:nvSpPr>
+        <p:spPr>
+          <a:xfrm>
+            <a:off x="7772400" y="6903720"/>
+            <a:ext cx="6400800" cy="502920"/>
           </a:xfrm>
           <a:prstGeom prst="rect">
             <a:avLst/>
@@ -1487,14 +1702,37 @@
       </p:sp>
       <p:sp>
         <p:nvSpPr>
-          <p:cNvPr id="18" name="Shape 14"/>
-          <p:cNvSpPr/>
-          <p:nvPr/>
-        </p:nvSpPr>
-        <p:spPr>
-          <a:xfrm>
-            <a:off x="7772400" y="5623560"/>
-            <a:ext cx="6400800" cy="6583680"/>
+          <p:cNvPr id="25" name="Shape 21"/>
+          <p:cNvSpPr/>
+          <p:nvPr/>
+        </p:nvSpPr>
+        <p:spPr>
+          <a:xfrm>
+            <a:off x="7772400" y="7488936"/>
+            <a:ext cx="2011680" cy="0"/>
+          </a:xfrm>
+          <a:prstGeom prst="line">
+            <a:avLst/>
+          </a:prstGeom>
+          <a:noFill/>
+          <a:ln w="38100">
+            <a:solidFill>
+              <a:srgbClr val="C8102E"/>
+            </a:solidFill>
+            <a:prstDash val="solid"/>
+          </a:ln>
+        </p:spPr>
+      </p:sp>
+      <p:sp>
+        <p:nvSpPr>
+          <p:cNvPr id="26" name="Shape 22"/>
+          <p:cNvSpPr/>
+          <p:nvPr/>
+        </p:nvSpPr>
+        <p:spPr>
+          <a:xfrm>
+            <a:off x="7772400" y="7653528"/>
+            <a:ext cx="6400800" cy="8961120"/>
           </a:xfrm>
           <a:prstGeom prst="roundRect">
             <a:avLst>
@@ -1514,14 +1752,14 @@
       </p:sp>
       <p:sp>
         <p:nvSpPr>
-          <p:cNvPr id="19" name="Text 15"/>
-          <p:cNvSpPr/>
-          <p:nvPr/>
-        </p:nvSpPr>
-        <p:spPr>
-          <a:xfrm>
-            <a:off x="7772400" y="5623560"/>
-            <a:ext cx="6400800" cy="6583680"/>
+          <p:cNvPr id="27" name="Text 23"/>
+          <p:cNvSpPr/>
+          <p:nvPr/>
+        </p:nvSpPr>
+        <p:spPr>
+          <a:xfrm>
+            <a:off x="8229600" y="7653528"/>
+            <a:ext cx="5486400" cy="8961120"/>
           </a:xfrm>
           <a:prstGeom prst="rect">
             <a:avLst/>
@@ -1534,10 +1772,13 @@
           <a:lstStyle/>
           <a:p>
             <a:pPr algn="ctr" indent="0" marL="0">
+              <a:lnSpc>
+                <a:spcPct val="130000"/>
+              </a:lnSpc>
               <a:buNone/>
             </a:pPr>
             <a:r>
-              <a:rPr lang="en-US" sz="2000" dirty="0">
+              <a:rPr lang="en-US" sz="2000" i="1" dirty="0">
                 <a:solidFill>
                   <a:srgbClr val="52606D"/>
                 </a:solidFill>
@@ -1545,26 +1786,95 @@
                 <a:ea typeface="Open Sans" pitchFamily="34" charset="-122"/>
                 <a:cs typeface="Open Sans" pitchFamily="34" charset="-120"/>
               </a:rPr>
-              <a:t>[ Figure 1 — paste your chart or image ]</a:t>
+              <a:t>Your main figure or table.</a:t>
             </a:r>
             <a:endParaRPr lang="en-US" sz="2000" dirty="0"/>
           </a:p>
-        </p:txBody>
-      </p:sp>
-      <p:sp>
-        <p:nvSpPr>
-          <p:cNvPr id="20" name="Shape 16"/>
-          <p:cNvSpPr/>
-          <p:nvPr/>
-        </p:nvSpPr>
-        <p:spPr>
-          <a:xfrm>
-            <a:off x="7772400" y="12664440"/>
-            <a:ext cx="6400800" cy="5669280"/>
+          <a:p>
+            <a:pPr algn="ctr" indent="0" marL="0">
+              <a:lnSpc>
+                <a:spcPct val="130000"/>
+              </a:lnSpc>
+              <a:buNone/>
+            </a:pPr>
+            <a:endParaRPr lang="en-US" sz="2000" dirty="0"/>
+          </a:p>
+          <a:p>
+            <a:pPr algn="ctr" indent="0" marL="0">
+              <a:lnSpc>
+                <a:spcPct val="130000"/>
+              </a:lnSpc>
+              <a:buNone/>
+            </a:pPr>
+            <a:r>
+              <a:rPr lang="en-US" sz="2000" i="1" dirty="0">
+                <a:solidFill>
+                  <a:srgbClr val="52606D"/>
+                </a:solidFill>
+                <a:latin typeface="Open Sans" pitchFamily="34" charset="0"/>
+                <a:ea typeface="Open Sans" pitchFamily="34" charset="-122"/>
+                <a:cs typeface="Open Sans" pitchFamily="34" charset="-120"/>
+              </a:rPr>
+              <a:t>Lead with the result, not the method —</a:t>
+            </a:r>
+            <a:endParaRPr lang="en-US" sz="2000" dirty="0"/>
+          </a:p>
+          <a:p>
+            <a:pPr algn="ctr" indent="0" marL="0">
+              <a:lnSpc>
+                <a:spcPct val="130000"/>
+              </a:lnSpc>
+              <a:buNone/>
+            </a:pPr>
+            <a:r>
+              <a:rPr lang="en-US" sz="2000" i="1" dirty="0">
+                <a:solidFill>
+                  <a:srgbClr val="52606D"/>
+                </a:solidFill>
+                <a:latin typeface="Open Sans" pitchFamily="34" charset="0"/>
+                <a:ea typeface="Open Sans" pitchFamily="34" charset="-122"/>
+                <a:cs typeface="Open Sans" pitchFamily="34" charset="-120"/>
+              </a:rPr>
+              <a:t>label the axes and give numbers</a:t>
+            </a:r>
+            <a:endParaRPr lang="en-US" sz="2000" dirty="0"/>
+          </a:p>
+          <a:p>
+            <a:pPr algn="ctr" indent="0" marL="0">
+              <a:lnSpc>
+                <a:spcPct val="130000"/>
+              </a:lnSpc>
+              <a:buNone/>
+            </a:pPr>
+            <a:r>
+              <a:rPr lang="en-US" sz="2000" i="1" dirty="0">
+                <a:solidFill>
+                  <a:srgbClr val="52606D"/>
+                </a:solidFill>
+                <a:latin typeface="Open Sans" pitchFamily="34" charset="0"/>
+                <a:ea typeface="Open Sans" pitchFamily="34" charset="-122"/>
+                <a:cs typeface="Open Sans" pitchFamily="34" charset="-120"/>
+              </a:rPr>
+              <a:t>with 95% confidence intervals.</a:t>
+            </a:r>
+            <a:endParaRPr lang="en-US" sz="2000" dirty="0"/>
+          </a:p>
+        </p:txBody>
+      </p:sp>
+      <p:sp>
+        <p:nvSpPr>
+          <p:cNvPr id="28" name="Shape 24"/>
+          <p:cNvSpPr/>
+          <p:nvPr/>
+        </p:nvSpPr>
+        <p:spPr>
+          <a:xfrm>
+            <a:off x="7772400" y="17071848"/>
+            <a:ext cx="6400800" cy="6035040"/>
           </a:xfrm>
           <a:prstGeom prst="roundRect">
             <a:avLst>
-              <a:gd name="adj" fmla="val 806"/>
+              <a:gd name="adj" fmla="val 758"/>
             </a:avLst>
           </a:prstGeom>
           <a:solidFill>
@@ -1580,14 +1890,14 @@
       </p:sp>
       <p:sp>
         <p:nvSpPr>
-          <p:cNvPr id="21" name="Text 17"/>
-          <p:cNvSpPr/>
-          <p:nvPr/>
-        </p:nvSpPr>
-        <p:spPr>
-          <a:xfrm>
-            <a:off x="7772400" y="12664440"/>
-            <a:ext cx="6400800" cy="5669280"/>
+          <p:cNvPr id="29" name="Text 25"/>
+          <p:cNvSpPr/>
+          <p:nvPr/>
+        </p:nvSpPr>
+        <p:spPr>
+          <a:xfrm>
+            <a:off x="8229600" y="17071848"/>
+            <a:ext cx="5486400" cy="6035040"/>
           </a:xfrm>
           <a:prstGeom prst="rect">
             <a:avLst/>
@@ -1600,118 +1910,60 @@
           <a:lstStyle/>
           <a:p>
             <a:pPr algn="ctr" indent="0" marL="0">
-              <a:buNone/>
-            </a:pPr>
-            <a:r>
-              <a:rPr lang="en-US" sz="2000" dirty="0">
-                <a:solidFill>
-                  <a:srgbClr val="52606D"/>
-                </a:solidFill>
-                <a:latin typeface="Open Sans" pitchFamily="34" charset="0"/>
-                <a:ea typeface="Open Sans" pitchFamily="34" charset="-122"/>
-                <a:cs typeface="Open Sans" pitchFamily="34" charset="-120"/>
-              </a:rPr>
-              <a:t>[ Table 1 / Figure 2 ]</a:t>
-            </a:r>
-            <a:endParaRPr lang="en-US" sz="2000" dirty="0"/>
-          </a:p>
-        </p:txBody>
-      </p:sp>
-      <p:sp>
-        <p:nvSpPr>
-          <p:cNvPr id="22" name="Text 18"/>
-          <p:cNvSpPr/>
-          <p:nvPr/>
-        </p:nvSpPr>
-        <p:spPr>
-          <a:xfrm>
-            <a:off x="7772400" y="18790920"/>
-            <a:ext cx="6400800" cy="1280160"/>
-          </a:xfrm>
-          <a:prstGeom prst="rect">
-            <a:avLst/>
-          </a:prstGeom>
-          <a:noFill/>
-          <a:ln/>
-        </p:spPr>
-        <p:txBody>
-          <a:bodyPr wrap="square" rtlCol="0" anchor="t"/>
-          <a:lstStyle/>
-          <a:p>
-            <a:pPr indent="0" marL="0">
               <a:lnSpc>
                 <a:spcPct val="130000"/>
               </a:lnSpc>
               <a:buNone/>
             </a:pPr>
             <a:r>
-              <a:rPr lang="en-US" sz="2200" dirty="0">
-                <a:solidFill>
-                  <a:srgbClr val="252525"/>
+              <a:rPr lang="en-US" sz="2000" i="1" dirty="0">
+                <a:solidFill>
+                  <a:srgbClr val="52606D"/>
                 </a:solidFill>
                 <a:latin typeface="Open Sans" pitchFamily="34" charset="0"/>
                 <a:ea typeface="Open Sans" pitchFamily="34" charset="-122"/>
                 <a:cs typeface="Open Sans" pitchFamily="34" charset="-120"/>
               </a:rPr>
-              <a:t>[ One or two sentences highlighting the key finding. ]</a:t>
-            </a:r>
-            <a:endParaRPr lang="en-US" sz="2200" dirty="0"/>
-          </a:p>
-        </p:txBody>
-      </p:sp>
-      <p:sp>
-        <p:nvSpPr>
-          <p:cNvPr id="23" name="Text 19"/>
-          <p:cNvSpPr/>
-          <p:nvPr/>
-        </p:nvSpPr>
-        <p:spPr>
-          <a:xfrm>
-            <a:off x="14721840" y="4937760"/>
-            <a:ext cx="6400800" cy="548640"/>
-          </a:xfrm>
-          <a:prstGeom prst="rect">
-            <a:avLst/>
-          </a:prstGeom>
-          <a:noFill/>
-          <a:ln/>
-        </p:spPr>
-        <p:txBody>
-          <a:bodyPr wrap="square" rtlCol="0" anchor="ctr"/>
-          <a:lstStyle/>
-          <a:p>
-            <a:pPr indent="0" marL="0">
+              <a:t>A second figure or a key table —</a:t>
+            </a:r>
+            <a:endParaRPr lang="en-US" sz="2000" dirty="0"/>
+          </a:p>
+          <a:p>
+            <a:pPr algn="ctr" indent="0" marL="0">
+              <a:lnSpc>
+                <a:spcPct val="130000"/>
+              </a:lnSpc>
               <a:buNone/>
             </a:pPr>
             <a:r>
-              <a:rPr lang="en-US" sz="3000" b="1" dirty="0">
-                <a:solidFill>
-                  <a:srgbClr val="74101F"/>
-                </a:solidFill>
-                <a:latin typeface="Montserrat" pitchFamily="34" charset="0"/>
-                <a:ea typeface="Montserrat" pitchFamily="34" charset="-122"/>
-                <a:cs typeface="Montserrat" pitchFamily="34" charset="-120"/>
-              </a:rPr>
-              <a:t>Conclusions &amp; interpretation</a:t>
-            </a:r>
-            <a:endParaRPr lang="en-US" sz="3000" dirty="0"/>
-          </a:p>
-        </p:txBody>
-      </p:sp>
-      <p:sp>
-        <p:nvSpPr>
-          <p:cNvPr id="24" name="Shape 20"/>
-          <p:cNvSpPr/>
-          <p:nvPr/>
-        </p:nvSpPr>
-        <p:spPr>
-          <a:xfrm>
-            <a:off x="14721840" y="5623560"/>
-            <a:ext cx="6400800" cy="5486400"/>
+              <a:rPr lang="en-US" sz="2000" i="1" dirty="0">
+                <a:solidFill>
+                  <a:srgbClr val="52606D"/>
+                </a:solidFill>
+                <a:latin typeface="Open Sans" pitchFamily="34" charset="0"/>
+                <a:ea typeface="Open Sans" pitchFamily="34" charset="-122"/>
+                <a:cs typeface="Open Sans" pitchFamily="34" charset="-120"/>
+              </a:rPr>
+              <a:t>only if it adds something new.</a:t>
+            </a:r>
+            <a:endParaRPr lang="en-US" sz="2000" dirty="0"/>
+          </a:p>
+        </p:txBody>
+      </p:sp>
+      <p:sp>
+        <p:nvSpPr>
+          <p:cNvPr id="30" name="Shape 26"/>
+          <p:cNvSpPr/>
+          <p:nvPr/>
+        </p:nvSpPr>
+        <p:spPr>
+          <a:xfrm>
+            <a:off x="7772400" y="23564088"/>
+            <a:ext cx="6400800" cy="2377440"/>
           </a:xfrm>
           <a:prstGeom prst="roundRect">
             <a:avLst>
-              <a:gd name="adj" fmla="val 833"/>
+              <a:gd name="adj" fmla="val 1923"/>
             </a:avLst>
           </a:prstGeom>
           <a:solidFill>
@@ -1727,14 +1979,14 @@
       </p:sp>
       <p:sp>
         <p:nvSpPr>
-          <p:cNvPr id="25" name="Text 21"/>
-          <p:cNvSpPr/>
-          <p:nvPr/>
-        </p:nvSpPr>
-        <p:spPr>
-          <a:xfrm>
-            <a:off x="15041880" y="5897880"/>
-            <a:ext cx="5760720" cy="4937760"/>
+          <p:cNvPr id="31" name="Text 27"/>
+          <p:cNvSpPr/>
+          <p:nvPr/>
+        </p:nvSpPr>
+        <p:spPr>
+          <a:xfrm>
+            <a:off x="8138160" y="23838408"/>
+            <a:ext cx="5669280" cy="1828800"/>
           </a:xfrm>
           <a:prstGeom prst="rect">
             <a:avLst/>
@@ -1753,15 +2005,32 @@
               <a:buNone/>
             </a:pPr>
             <a:r>
-              <a:rPr lang="en-US" sz="2200" dirty="0">
-                <a:solidFill>
-                  <a:srgbClr val="252525"/>
+              <a:rPr lang="en-US" sz="2200" b="1" dirty="0">
+                <a:solidFill>
+                  <a:srgbClr val="74101F"/>
                 </a:solidFill>
                 <a:latin typeface="Open Sans" pitchFamily="34" charset="0"/>
                 <a:ea typeface="Open Sans" pitchFamily="34" charset="-122"/>
                 <a:cs typeface="Open Sans" pitchFamily="34" charset="-120"/>
               </a:rPr>
-              <a:t>[ Main finding · what it means · implication for Nordic lung-cancer care or research. ]</a:t>
+              <a:t>Key numbers — </a:t>
+            </a:r>
+            <a:pPr indent="0" marL="0">
+              <a:lnSpc>
+                <a:spcPct val="130000"/>
+              </a:lnSpc>
+              <a:buNone/>
+            </a:pPr>
+            <a:r>
+              <a:rPr lang="en-US" sz="2200" i="1" dirty="0">
+                <a:solidFill>
+                  <a:srgbClr val="52606D"/>
+                </a:solidFill>
+                <a:latin typeface="Open Sans" pitchFamily="34" charset="0"/>
+                <a:ea typeface="Open Sans" pitchFamily="34" charset="-122"/>
+                <a:cs typeface="Open Sans" pitchFamily="34" charset="-120"/>
+              </a:rPr>
+              <a:t>report effect sizes with confidence intervals, not p-values alone.</a:t>
             </a:r>
             <a:endParaRPr lang="en-US" sz="2200" dirty="0"/>
           </a:p>
@@ -1769,14 +2038,14 @@
       </p:sp>
       <p:sp>
         <p:nvSpPr>
-          <p:cNvPr id="26" name="Text 22"/>
-          <p:cNvSpPr/>
-          <p:nvPr/>
-        </p:nvSpPr>
-        <p:spPr>
-          <a:xfrm>
-            <a:off x="14721840" y="11750040"/>
-            <a:ext cx="6400800" cy="548640"/>
+          <p:cNvPr id="32" name="Text 28"/>
+          <p:cNvSpPr/>
+          <p:nvPr/>
+        </p:nvSpPr>
+        <p:spPr>
+          <a:xfrm>
+            <a:off x="14721840" y="6903720"/>
+            <a:ext cx="6400800" cy="502920"/>
           </a:xfrm>
           <a:prstGeom prst="rect">
             <a:avLst/>
@@ -1800,7 +2069,7 @@
                 <a:ea typeface="Montserrat" pitchFamily="34" charset="-122"/>
                 <a:cs typeface="Montserrat" pitchFamily="34" charset="-120"/>
               </a:rPr>
-              <a:t>References</a:t>
+              <a:t>Conclusions &amp; interpretation</a:t>
             </a:r>
             <a:endParaRPr lang="en-US" sz="3000" dirty="0"/>
           </a:p>
@@ -1808,18 +2077,41 @@
       </p:sp>
       <p:sp>
         <p:nvSpPr>
-          <p:cNvPr id="27" name="Shape 23"/>
-          <p:cNvSpPr/>
-          <p:nvPr/>
-        </p:nvSpPr>
-        <p:spPr>
-          <a:xfrm>
-            <a:off x="14721840" y="12435840"/>
-            <a:ext cx="6400800" cy="3657600"/>
+          <p:cNvPr id="33" name="Shape 29"/>
+          <p:cNvSpPr/>
+          <p:nvPr/>
+        </p:nvSpPr>
+        <p:spPr>
+          <a:xfrm>
+            <a:off x="14721840" y="7488936"/>
+            <a:ext cx="2011680" cy="0"/>
+          </a:xfrm>
+          <a:prstGeom prst="line">
+            <a:avLst/>
+          </a:prstGeom>
+          <a:noFill/>
+          <a:ln w="38100">
+            <a:solidFill>
+              <a:srgbClr val="C8102E"/>
+            </a:solidFill>
+            <a:prstDash val="solid"/>
+          </a:ln>
+        </p:spPr>
+      </p:sp>
+      <p:sp>
+        <p:nvSpPr>
+          <p:cNvPr id="34" name="Shape 30"/>
+          <p:cNvSpPr/>
+          <p:nvPr/>
+        </p:nvSpPr>
+        <p:spPr>
+          <a:xfrm>
+            <a:off x="14721840" y="7653528"/>
+            <a:ext cx="6400800" cy="6400800"/>
           </a:xfrm>
           <a:prstGeom prst="roundRect">
             <a:avLst>
-              <a:gd name="adj" fmla="val 1250"/>
+              <a:gd name="adj" fmla="val 714"/>
             </a:avLst>
           </a:prstGeom>
           <a:solidFill>
@@ -1835,14 +2127,14 @@
       </p:sp>
       <p:sp>
         <p:nvSpPr>
-          <p:cNvPr id="28" name="Text 24"/>
-          <p:cNvSpPr/>
-          <p:nvPr/>
-        </p:nvSpPr>
-        <p:spPr>
-          <a:xfrm>
-            <a:off x="15041880" y="12710160"/>
-            <a:ext cx="5760720" cy="3108960"/>
+          <p:cNvPr id="35" name="Text 31"/>
+          <p:cNvSpPr/>
+          <p:nvPr/>
+        </p:nvSpPr>
+        <p:spPr>
+          <a:xfrm>
+            <a:off x="15087600" y="7909560"/>
+            <a:ext cx="5669280" cy="5897880"/>
           </a:xfrm>
           <a:prstGeom prst="rect">
             <a:avLst/>
@@ -1861,70 +2153,30 @@
               <a:buNone/>
             </a:pPr>
             <a:r>
-              <a:rPr lang="en-US" sz="2200" dirty="0">
-                <a:solidFill>
-                  <a:srgbClr val="252525"/>
+              <a:rPr lang="en-US" sz="2200" i="1" dirty="0">
+                <a:solidFill>
+                  <a:srgbClr val="52606D"/>
                 </a:solidFill>
                 <a:latin typeface="Open Sans" pitchFamily="34" charset="0"/>
                 <a:ea typeface="Open Sans" pitchFamily="34" charset="-122"/>
                 <a:cs typeface="Open Sans" pitchFamily="34" charset="-120"/>
               </a:rPr>
-              <a:t>[ 1. … ]</a:t>
+              <a:t>What the main finding means · one honest limitation · the implication for Nordic lung-cancer practice or research. Don’t overclaim.</a:t>
             </a:r>
             <a:endParaRPr lang="en-US" sz="2200" dirty="0"/>
           </a:p>
-          <a:p>
-            <a:pPr indent="0" marL="0">
-              <a:lnSpc>
-                <a:spcPct val="130000"/>
-              </a:lnSpc>
-              <a:buNone/>
-            </a:pPr>
-            <a:r>
-              <a:rPr lang="en-US" sz="2200" dirty="0">
-                <a:solidFill>
-                  <a:srgbClr val="252525"/>
-                </a:solidFill>
-                <a:latin typeface="Open Sans" pitchFamily="34" charset="0"/>
-                <a:ea typeface="Open Sans" pitchFamily="34" charset="-122"/>
-                <a:cs typeface="Open Sans" pitchFamily="34" charset="-120"/>
-              </a:rPr>
-              <a:t>[ 2. … ]</a:t>
-            </a:r>
-            <a:endParaRPr lang="en-US" sz="2200" dirty="0"/>
-          </a:p>
-          <a:p>
-            <a:pPr indent="0" marL="0">
-              <a:lnSpc>
-                <a:spcPct val="130000"/>
-              </a:lnSpc>
-              <a:buNone/>
-            </a:pPr>
-            <a:r>
-              <a:rPr lang="en-US" sz="2200" dirty="0">
-                <a:solidFill>
-                  <a:srgbClr val="252525"/>
-                </a:solidFill>
-                <a:latin typeface="Open Sans" pitchFamily="34" charset="0"/>
-                <a:ea typeface="Open Sans" pitchFamily="34" charset="-122"/>
-                <a:cs typeface="Open Sans" pitchFamily="34" charset="-120"/>
-              </a:rPr>
-              <a:t>[ 3. … ]</a:t>
-            </a:r>
-            <a:endParaRPr lang="en-US" sz="2200" dirty="0"/>
-          </a:p>
-        </p:txBody>
-      </p:sp>
-      <p:sp>
-        <p:nvSpPr>
-          <p:cNvPr id="29" name="Text 25"/>
-          <p:cNvSpPr/>
-          <p:nvPr/>
-        </p:nvSpPr>
-        <p:spPr>
-          <a:xfrm>
-            <a:off x="14721840" y="16733520"/>
-            <a:ext cx="6400800" cy="548640"/>
+        </p:txBody>
+      </p:sp>
+      <p:sp>
+        <p:nvSpPr>
+          <p:cNvPr id="36" name="Text 32"/>
+          <p:cNvSpPr/>
+          <p:nvPr/>
+        </p:nvSpPr>
+        <p:spPr>
+          <a:xfrm>
+            <a:off x="14721840" y="14602968"/>
+            <a:ext cx="6400800" cy="502920"/>
           </a:xfrm>
           <a:prstGeom prst="rect">
             <a:avLst/>
@@ -1948,7 +2200,7 @@
                 <a:ea typeface="Montserrat" pitchFamily="34" charset="-122"/>
                 <a:cs typeface="Montserrat" pitchFamily="34" charset="-120"/>
               </a:rPr>
-              <a:t>Acknowledgements &amp; funding</a:t>
+              <a:t>References</a:t>
             </a:r>
             <a:endParaRPr lang="en-US" sz="3000" dirty="0"/>
           </a:p>
@@ -1956,18 +2208,41 @@
       </p:sp>
       <p:sp>
         <p:nvSpPr>
-          <p:cNvPr id="30" name="Shape 26"/>
-          <p:cNvSpPr/>
-          <p:nvPr/>
-        </p:nvSpPr>
-        <p:spPr>
-          <a:xfrm>
-            <a:off x="14721840" y="17419320"/>
-            <a:ext cx="6400800" cy="2743200"/>
+          <p:cNvPr id="37" name="Shape 33"/>
+          <p:cNvSpPr/>
+          <p:nvPr/>
+        </p:nvSpPr>
+        <p:spPr>
+          <a:xfrm>
+            <a:off x="14721840" y="15188184"/>
+            <a:ext cx="2011680" cy="0"/>
+          </a:xfrm>
+          <a:prstGeom prst="line">
+            <a:avLst/>
+          </a:prstGeom>
+          <a:noFill/>
+          <a:ln w="38100">
+            <a:solidFill>
+              <a:srgbClr val="C8102E"/>
+            </a:solidFill>
+            <a:prstDash val="solid"/>
+          </a:ln>
+        </p:spPr>
+      </p:sp>
+      <p:sp>
+        <p:nvSpPr>
+          <p:cNvPr id="38" name="Shape 34"/>
+          <p:cNvSpPr/>
+          <p:nvPr/>
+        </p:nvSpPr>
+        <p:spPr>
+          <a:xfrm>
+            <a:off x="14721840" y="15352776"/>
+            <a:ext cx="6400800" cy="4023360"/>
           </a:xfrm>
           <a:prstGeom prst="roundRect">
             <a:avLst>
-              <a:gd name="adj" fmla="val 1667"/>
+              <a:gd name="adj" fmla="val 1136"/>
             </a:avLst>
           </a:prstGeom>
           <a:solidFill>
@@ -1983,14 +2258,14 @@
       </p:sp>
       <p:sp>
         <p:nvSpPr>
-          <p:cNvPr id="31" name="Text 27"/>
-          <p:cNvSpPr/>
-          <p:nvPr/>
-        </p:nvSpPr>
-        <p:spPr>
-          <a:xfrm>
-            <a:off x="15041880" y="17693640"/>
-            <a:ext cx="5760720" cy="2194560"/>
+          <p:cNvPr id="39" name="Text 35"/>
+          <p:cNvSpPr/>
+          <p:nvPr/>
+        </p:nvSpPr>
+        <p:spPr>
+          <a:xfrm>
+            <a:off x="15087600" y="15608808"/>
+            <a:ext cx="5669280" cy="3520440"/>
           </a:xfrm>
           <a:prstGeom prst="rect">
             <a:avLst/>
@@ -2009,15 +2284,15 @@
               <a:buNone/>
             </a:pPr>
             <a:r>
-              <a:rPr lang="en-US" sz="2200" dirty="0">
-                <a:solidFill>
-                  <a:srgbClr val="252525"/>
+              <a:rPr lang="en-US" sz="2200" i="1" dirty="0">
+                <a:solidFill>
+                  <a:srgbClr val="52606D"/>
                 </a:solidFill>
                 <a:latin typeface="Open Sans" pitchFamily="34" charset="0"/>
                 <a:ea typeface="Open Sans" pitchFamily="34" charset="-122"/>
                 <a:cs typeface="Open Sans" pitchFamily="34" charset="-120"/>
               </a:rPr>
-              <a:t>[ Funding sources, collaborators, contact. ]</a:t>
+              <a:t>3–5 key references, Vancouver style.</a:t>
             </a:r>
             <a:endParaRPr lang="en-US" sz="2200" dirty="0"/>
           </a:p>
@@ -2025,14 +2300,145 @@
       </p:sp>
       <p:sp>
         <p:nvSpPr>
-          <p:cNvPr id="32" name="Shape 28"/>
-          <p:cNvSpPr/>
-          <p:nvPr/>
-        </p:nvSpPr>
-        <p:spPr>
-          <a:xfrm>
-            <a:off x="0" y="28986480"/>
-            <a:ext cx="21387816" cy="1289304"/>
+          <p:cNvPr id="40" name="Text 36"/>
+          <p:cNvSpPr/>
+          <p:nvPr/>
+        </p:nvSpPr>
+        <p:spPr>
+          <a:xfrm>
+            <a:off x="14721840" y="19924776"/>
+            <a:ext cx="6400800" cy="502920"/>
+          </a:xfrm>
+          <a:prstGeom prst="rect">
+            <a:avLst/>
+          </a:prstGeom>
+          <a:noFill/>
+          <a:ln/>
+        </p:spPr>
+        <p:txBody>
+          <a:bodyPr wrap="square" rtlCol="0" anchor="ctr"/>
+          <a:lstStyle/>
+          <a:p>
+            <a:pPr indent="0" marL="0">
+              <a:buNone/>
+            </a:pPr>
+            <a:r>
+              <a:rPr lang="en-US" sz="3000" b="1" dirty="0">
+                <a:solidFill>
+                  <a:srgbClr val="74101F"/>
+                </a:solidFill>
+                <a:latin typeface="Montserrat" pitchFamily="34" charset="0"/>
+                <a:ea typeface="Montserrat" pitchFamily="34" charset="-122"/>
+                <a:cs typeface="Montserrat" pitchFamily="34" charset="-120"/>
+              </a:rPr>
+              <a:t>Acknowledgements &amp; funding</a:t>
+            </a:r>
+            <a:endParaRPr lang="en-US" sz="3000" dirty="0"/>
+          </a:p>
+        </p:txBody>
+      </p:sp>
+      <p:sp>
+        <p:nvSpPr>
+          <p:cNvPr id="41" name="Shape 37"/>
+          <p:cNvSpPr/>
+          <p:nvPr/>
+        </p:nvSpPr>
+        <p:spPr>
+          <a:xfrm>
+            <a:off x="14721840" y="20509992"/>
+            <a:ext cx="2011680" cy="0"/>
+          </a:xfrm>
+          <a:prstGeom prst="line">
+            <a:avLst/>
+          </a:prstGeom>
+          <a:noFill/>
+          <a:ln w="38100">
+            <a:solidFill>
+              <a:srgbClr val="C8102E"/>
+            </a:solidFill>
+            <a:prstDash val="solid"/>
+          </a:ln>
+        </p:spPr>
+      </p:sp>
+      <p:sp>
+        <p:nvSpPr>
+          <p:cNvPr id="42" name="Shape 38"/>
+          <p:cNvSpPr/>
+          <p:nvPr/>
+        </p:nvSpPr>
+        <p:spPr>
+          <a:xfrm>
+            <a:off x="14721840" y="20674584"/>
+            <a:ext cx="6400800" cy="3840480"/>
+          </a:xfrm>
+          <a:prstGeom prst="roundRect">
+            <a:avLst>
+              <a:gd name="adj" fmla="val 1190"/>
+            </a:avLst>
+          </a:prstGeom>
+          <a:solidFill>
+            <a:srgbClr val="FFF1F3"/>
+          </a:solidFill>
+          <a:ln w="12700">
+            <a:solidFill>
+              <a:srgbClr val="F2B8C2"/>
+            </a:solidFill>
+            <a:prstDash val="solid"/>
+          </a:ln>
+        </p:spPr>
+      </p:sp>
+      <p:sp>
+        <p:nvSpPr>
+          <p:cNvPr id="43" name="Text 39"/>
+          <p:cNvSpPr/>
+          <p:nvPr/>
+        </p:nvSpPr>
+        <p:spPr>
+          <a:xfrm>
+            <a:off x="15087600" y="20930616"/>
+            <a:ext cx="5669280" cy="3337560"/>
+          </a:xfrm>
+          <a:prstGeom prst="rect">
+            <a:avLst/>
+          </a:prstGeom>
+          <a:noFill/>
+          <a:ln/>
+        </p:spPr>
+        <p:txBody>
+          <a:bodyPr wrap="square" rtlCol="0" anchor="t"/>
+          <a:lstStyle/>
+          <a:p>
+            <a:pPr indent="0" marL="0">
+              <a:lnSpc>
+                <a:spcPct val="130000"/>
+              </a:lnSpc>
+              <a:buNone/>
+            </a:pPr>
+            <a:r>
+              <a:rPr lang="en-US" sz="2200" i="1" dirty="0">
+                <a:solidFill>
+                  <a:srgbClr val="52606D"/>
+                </a:solidFill>
+                <a:latin typeface="Open Sans" pitchFamily="34" charset="0"/>
+                <a:ea typeface="Open Sans" pitchFamily="34" charset="-122"/>
+                <a:cs typeface="Open Sans" pitchFamily="34" charset="-120"/>
+              </a:rPr>
+              <a:t>Funding sources, collaborators, and a contact email.</a:t>
+            </a:r>
+            <a:endParaRPr lang="en-US" sz="2200" dirty="0"/>
+          </a:p>
+        </p:txBody>
+      </p:sp>
+      <p:sp>
+        <p:nvSpPr>
+          <p:cNvPr id="44" name="Shape 40"/>
+          <p:cNvSpPr/>
+          <p:nvPr/>
+        </p:nvSpPr>
+        <p:spPr>
+          <a:xfrm>
+            <a:off x="0" y="28803600"/>
+            <a:ext cx="21387816" cy="1472184"/>
           </a:xfrm>
           <a:prstGeom prst="rect">
             <a:avLst/>
@@ -2045,7 +2451,7 @@
       </p:sp>
       <p:pic>
         <p:nvPicPr>
-          <p:cNvPr id="33" name="Image 2" descr="/Users/heidiandersen/ntog/ntog-logo-1024.png">    </p:cNvPr>
+          <p:cNvPr id="45" name="Image 2" descr="/Users/heidiandersen/ntog/ntog-logo-1024.png">    </p:cNvPr>
           <p:cNvPicPr>
             <a:picLocks noChangeAspect="1"/>
           </p:cNvPicPr>
@@ -2059,8 +2465,8 @@
         </p:blipFill>
         <p:spPr>
           <a:xfrm>
-            <a:off x="822960" y="29215080"/>
-            <a:ext cx="822960" cy="822960"/>
+            <a:off x="822960" y="29059632"/>
+            <a:ext cx="960120" cy="960120"/>
           </a:xfrm>
           <a:prstGeom prst="rect">
             <a:avLst/>
@@ -2069,14 +2475,14 @@
       </p:pic>
       <p:sp>
         <p:nvSpPr>
-          <p:cNvPr id="34" name="Text 29"/>
-          <p:cNvSpPr/>
-          <p:nvPr/>
-        </p:nvSpPr>
-        <p:spPr>
-          <a:xfrm>
-            <a:off x="1920240" y="28986480"/>
-            <a:ext cx="18653760" cy="1289304"/>
+          <p:cNvPr id="46" name="Text 41"/>
+          <p:cNvSpPr/>
+          <p:nvPr/>
+        </p:nvSpPr>
+        <p:spPr>
+          <a:xfrm>
+            <a:off x="2103120" y="28803600"/>
+            <a:ext cx="18470880" cy="1472184"/>
           </a:xfrm>
           <a:prstGeom prst="rect">
             <a:avLst/>
@@ -2100,7 +2506,7 @@
                 <a:ea typeface="Montserrat" pitchFamily="34" charset="-122"/>
                 <a:cs typeface="Montserrat" pitchFamily="34" charset="-120"/>
               </a:rPr>
-              <a:t>Contact: [ email@institution ]      ntog.org/ntog2027      #NLCS2027</a:t>
+              <a:t>Contact: [ email@institution ]      ·      ntog.org/ntog2027      ·      #NLCS2027</a:t>
             </a:r>
             <a:endParaRPr lang="en-US" sz="2000" dirty="0"/>
           </a:p>

</xml_diff>

<commit_message>
A1 poster template: stronger layout + how-to-write guidance (#27)
Improve the NLCS 2027 poster (594x841 mm) for poster best practice and make the
placeholders teach good abstract writing:
- Add a full-width 'Take-home message' strip under the header (the one line a
  passer-by should remember).
- Red rule under each section heading; results figures enlarged to dominate.
- Replace bracket placeholders with concise guidance on how to write each
  section well (Background: problem/why/how common + gap; Aim: one specific
  question; Methods: design/data/analysis, enough to judge validity; Results:
  lead with the result, numbers with 95% CI; Conclusions: meaning + one
  limitation + implication, don't overclaim; plus a 'Key numbers' note).
- Results-forward title prompt; underline-the-presenter author note.

Generated via brand-carousel/pptx/build.js (local, gitignored). Review in
PowerPoint — no LibreOffice here to render.

Co-authored-by: Claude Opus 4.8 <noreply@anthropic.com>
</commit_message>
<xml_diff>
--- a/ntog2027/nlcs2027-poster-A1-template.pptx
+++ b/ntog2027/nlcs2027-poster-A1-template.pptx
@@ -970,8 +970,8 @@
         </p:nvSpPr>
         <p:spPr>
           <a:xfrm>
-            <a:off x="3931920" y="1371600"/>
-            <a:ext cx="16642080" cy="1554480"/>
+            <a:off x="3931920" y="1325880"/>
+            <a:ext cx="16642080" cy="1645920"/>
           </a:xfrm>
           <a:prstGeom prst="rect">
             <a:avLst/>
@@ -987,7 +987,7 @@
               <a:buNone/>
             </a:pPr>
             <a:r>
-              <a:rPr lang="en-US" sz="4000" b="1" dirty="0">
+              <a:rPr lang="en-US" sz="4400" b="1" dirty="0">
                 <a:solidFill>
                   <a:srgbClr val="FFFFFF"/>
                 </a:solidFill>
@@ -995,9 +995,9 @@
                 <a:ea typeface="Montserrat" pitchFamily="34" charset="-122"/>
                 <a:cs typeface="Montserrat" pitchFamily="34" charset="-120"/>
               </a:rPr>
-              <a:t>[ Poster title goes here — keep it short and specific ]</a:t>
-            </a:r>
-            <a:endParaRPr lang="en-US" sz="4000" dirty="0"/>
+              <a:t>Your poster title — short, specific, and results-forward</a:t>
+            </a:r>
+            <a:endParaRPr lang="en-US" sz="4400" dirty="0"/>
           </a:p>
         </p:txBody>
       </p:sp>
@@ -1009,7 +1009,7 @@
         </p:nvSpPr>
         <p:spPr>
           <a:xfrm>
-            <a:off x="3931920" y="3063240"/>
+            <a:off x="3931920" y="3108960"/>
             <a:ext cx="16642080" cy="457200"/>
           </a:xfrm>
           <a:prstGeom prst="rect">
@@ -1034,7 +1034,7 @@
                 <a:ea typeface="Open Sans" pitchFamily="34" charset="-122"/>
                 <a:cs typeface="Open Sans" pitchFamily="34" charset="-120"/>
               </a:rPr>
-              <a:t>[ Author A¹, Author B², Author C¹ ]</a:t>
+              <a:t>Author A¹, Author B², Author C¹   (underline the presenting author)</a:t>
             </a:r>
             <a:endParaRPr lang="en-US" sz="2200" dirty="0"/>
           </a:p>
@@ -1048,7 +1048,7 @@
         </p:nvSpPr>
         <p:spPr>
           <a:xfrm>
-            <a:off x="3931920" y="3611880"/>
+            <a:off x="3931920" y="3657600"/>
             <a:ext cx="16642080" cy="457200"/>
           </a:xfrm>
           <a:prstGeom prst="rect">
@@ -1073,7 +1073,7 @@
                 <a:ea typeface="Open Sans" pitchFamily="34" charset="-122"/>
                 <a:cs typeface="Open Sans" pitchFamily="34" charset="-120"/>
               </a:rPr>
-              <a:t>[ ¹ Affiliation, City, Country · ² Affiliation, City, Country ]</a:t>
+              <a:t>¹ Affiliation, City, Country   ·   ² Affiliation, City, Country</a:t>
             </a:r>
             <a:endParaRPr lang="en-US" sz="1600" dirty="0"/>
           </a:p>
@@ -1081,57 +1081,18 @@
       </p:sp>
       <p:sp>
         <p:nvSpPr>
-          <p:cNvPr id="8" name="Text 4"/>
-          <p:cNvSpPr/>
-          <p:nvPr/>
-        </p:nvSpPr>
-        <p:spPr>
-          <a:xfrm>
-            <a:off x="822960" y="4937760"/>
-            <a:ext cx="6400800" cy="548640"/>
-          </a:xfrm>
-          <a:prstGeom prst="rect">
-            <a:avLst/>
-          </a:prstGeom>
-          <a:noFill/>
-          <a:ln/>
-        </p:spPr>
-        <p:txBody>
-          <a:bodyPr wrap="square" rtlCol="0" anchor="ctr"/>
-          <a:lstStyle/>
-          <a:p>
-            <a:pPr indent="0" marL="0">
-              <a:buNone/>
-            </a:pPr>
-            <a:r>
-              <a:rPr lang="en-US" sz="3000" b="1" dirty="0">
-                <a:solidFill>
-                  <a:srgbClr val="74101F"/>
-                </a:solidFill>
-                <a:latin typeface="Montserrat" pitchFamily="34" charset="0"/>
-                <a:ea typeface="Montserrat" pitchFamily="34" charset="-122"/>
-                <a:cs typeface="Montserrat" pitchFamily="34" charset="-120"/>
-              </a:rPr>
-              <a:t>Background</a:t>
-            </a:r>
-            <a:endParaRPr lang="en-US" sz="3000" dirty="0"/>
-          </a:p>
-        </p:txBody>
-      </p:sp>
-      <p:sp>
-        <p:nvSpPr>
-          <p:cNvPr id="9" name="Shape 5"/>
-          <p:cNvSpPr/>
-          <p:nvPr/>
-        </p:nvSpPr>
-        <p:spPr>
-          <a:xfrm>
-            <a:off x="822960" y="5623560"/>
-            <a:ext cx="6400800" cy="4023360"/>
+          <p:cNvPr id="8" name="Shape 4"/>
+          <p:cNvSpPr/>
+          <p:nvPr/>
+        </p:nvSpPr>
+        <p:spPr>
+          <a:xfrm>
+            <a:off x="822960" y="4709160"/>
+            <a:ext cx="19741896" cy="1783080"/>
           </a:xfrm>
           <a:prstGeom prst="roundRect">
             <a:avLst>
-              <a:gd name="adj" fmla="val 1136"/>
+              <a:gd name="adj" fmla="val 3077"/>
             </a:avLst>
           </a:prstGeom>
           <a:solidFill>
@@ -1147,14 +1108,73 @@
       </p:sp>
       <p:sp>
         <p:nvSpPr>
+          <p:cNvPr id="9" name="Shape 5"/>
+          <p:cNvSpPr/>
+          <p:nvPr/>
+        </p:nvSpPr>
+        <p:spPr>
+          <a:xfrm>
+            <a:off x="822960" y="4709160"/>
+            <a:ext cx="164592" cy="1783080"/>
+          </a:xfrm>
+          <a:prstGeom prst="rect">
+            <a:avLst/>
+          </a:prstGeom>
+          <a:solidFill>
+            <a:srgbClr val="C8102E"/>
+          </a:solidFill>
+          <a:ln/>
+        </p:spPr>
+      </p:sp>
+      <p:sp>
+        <p:nvSpPr>
           <p:cNvPr id="10" name="Text 6"/>
           <p:cNvSpPr/>
           <p:nvPr/>
         </p:nvSpPr>
         <p:spPr>
           <a:xfrm>
-            <a:off x="1143000" y="5897880"/>
-            <a:ext cx="5760720" cy="3474720"/>
+            <a:off x="1325880" y="4882896"/>
+            <a:ext cx="18836640" cy="457200"/>
+          </a:xfrm>
+          <a:prstGeom prst="rect">
+            <a:avLst/>
+          </a:prstGeom>
+          <a:noFill/>
+          <a:ln/>
+        </p:spPr>
+        <p:txBody>
+          <a:bodyPr wrap="square" rtlCol="0" anchor="ctr"/>
+          <a:lstStyle/>
+          <a:p>
+            <a:pPr indent="0" marL="0">
+              <a:buNone/>
+            </a:pPr>
+            <a:r>
+              <a:rPr lang="en-US" sz="2000" b="1" spc="100" kern="0" dirty="0">
+                <a:solidFill>
+                  <a:srgbClr val="74101F"/>
+                </a:solidFill>
+                <a:latin typeface="Montserrat" pitchFamily="34" charset="0"/>
+                <a:ea typeface="Montserrat" pitchFamily="34" charset="-122"/>
+                <a:cs typeface="Montserrat" pitchFamily="34" charset="-120"/>
+              </a:rPr>
+              <a:t>TAKE-HOME MESSAGE</a:t>
+            </a:r>
+            <a:endParaRPr lang="en-US" sz="2000" dirty="0"/>
+          </a:p>
+        </p:txBody>
+      </p:sp>
+      <p:sp>
+        <p:nvSpPr>
+          <p:cNvPr id="11" name="Text 7"/>
+          <p:cNvSpPr/>
+          <p:nvPr/>
+        </p:nvSpPr>
+        <p:spPr>
+          <a:xfrm>
+            <a:off x="1325880" y="5340096"/>
+            <a:ext cx="18836640" cy="1005840"/>
           </a:xfrm>
           <a:prstGeom prst="rect">
             <a:avLst/>
@@ -1167,36 +1187,33 @@
           <a:lstStyle/>
           <a:p>
             <a:pPr indent="0" marL="0">
-              <a:lnSpc>
-                <a:spcPct val="130000"/>
-              </a:lnSpc>
               <a:buNone/>
             </a:pPr>
             <a:r>
-              <a:rPr lang="en-US" sz="2200" dirty="0">
-                <a:solidFill>
-                  <a:srgbClr val="252525"/>
+              <a:rPr lang="en-US" sz="2400" i="1" dirty="0">
+                <a:solidFill>
+                  <a:srgbClr val="52606D"/>
                 </a:solidFill>
                 <a:latin typeface="Open Sans" pitchFamily="34" charset="0"/>
                 <a:ea typeface="Open Sans" pitchFamily="34" charset="-122"/>
                 <a:cs typeface="Open Sans" pitchFamily="34" charset="-120"/>
               </a:rPr>
-              <a:t>[ Clinical problem; why it matters; how common in the Nordic setting. ]</a:t>
-            </a:r>
-            <a:endParaRPr lang="en-US" sz="2200" dirty="0"/>
-          </a:p>
-        </p:txBody>
-      </p:sp>
-      <p:sp>
-        <p:nvSpPr>
-          <p:cNvPr id="11" name="Text 7"/>
-          <p:cNvSpPr/>
-          <p:nvPr/>
-        </p:nvSpPr>
-        <p:spPr>
-          <a:xfrm>
-            <a:off x="822960" y="10287000"/>
-            <a:ext cx="6400800" cy="548640"/>
+              <a:t>The one sentence a passer-by should remember — your single most important, specific finding.</a:t>
+            </a:r>
+            <a:endParaRPr lang="en-US" sz="2400" dirty="0"/>
+          </a:p>
+        </p:txBody>
+      </p:sp>
+      <p:sp>
+        <p:nvSpPr>
+          <p:cNvPr id="12" name="Text 8"/>
+          <p:cNvSpPr/>
+          <p:nvPr/>
+        </p:nvSpPr>
+        <p:spPr>
+          <a:xfrm>
+            <a:off x="822960" y="6903720"/>
+            <a:ext cx="6400800" cy="502920"/>
           </a:xfrm>
           <a:prstGeom prst="rect">
             <a:avLst/>
@@ -1220,7 +1237,7 @@
                 <a:ea typeface="Montserrat" pitchFamily="34" charset="-122"/>
                 <a:cs typeface="Montserrat" pitchFamily="34" charset="-120"/>
               </a:rPr>
-              <a:t>Aim</a:t>
+              <a:t>Background</a:t>
             </a:r>
             <a:endParaRPr lang="en-US" sz="3000" dirty="0"/>
           </a:p>
@@ -1228,18 +1245,41 @@
       </p:sp>
       <p:sp>
         <p:nvSpPr>
-          <p:cNvPr id="12" name="Shape 8"/>
-          <p:cNvSpPr/>
-          <p:nvPr/>
-        </p:nvSpPr>
-        <p:spPr>
-          <a:xfrm>
-            <a:off x="822960" y="10972800"/>
-            <a:ext cx="6400800" cy="2377440"/>
+          <p:cNvPr id="13" name="Shape 9"/>
+          <p:cNvSpPr/>
+          <p:nvPr/>
+        </p:nvSpPr>
+        <p:spPr>
+          <a:xfrm>
+            <a:off x="822960" y="7488936"/>
+            <a:ext cx="2011680" cy="0"/>
+          </a:xfrm>
+          <a:prstGeom prst="line">
+            <a:avLst/>
+          </a:prstGeom>
+          <a:noFill/>
+          <a:ln w="38100">
+            <a:solidFill>
+              <a:srgbClr val="C8102E"/>
+            </a:solidFill>
+            <a:prstDash val="solid"/>
+          </a:ln>
+        </p:spPr>
+      </p:sp>
+      <p:sp>
+        <p:nvSpPr>
+          <p:cNvPr id="14" name="Shape 10"/>
+          <p:cNvSpPr/>
+          <p:nvPr/>
+        </p:nvSpPr>
+        <p:spPr>
+          <a:xfrm>
+            <a:off x="822960" y="7653528"/>
+            <a:ext cx="6400800" cy="4389120"/>
           </a:xfrm>
           <a:prstGeom prst="roundRect">
             <a:avLst>
-              <a:gd name="adj" fmla="val 1923"/>
+              <a:gd name="adj" fmla="val 1042"/>
             </a:avLst>
           </a:prstGeom>
           <a:solidFill>
@@ -1255,14 +1295,14 @@
       </p:sp>
       <p:sp>
         <p:nvSpPr>
-          <p:cNvPr id="13" name="Text 9"/>
-          <p:cNvSpPr/>
-          <p:nvPr/>
-        </p:nvSpPr>
-        <p:spPr>
-          <a:xfrm>
-            <a:off x="1143000" y="11247120"/>
-            <a:ext cx="5760720" cy="1828800"/>
+          <p:cNvPr id="15" name="Text 11"/>
+          <p:cNvSpPr/>
+          <p:nvPr/>
+        </p:nvSpPr>
+        <p:spPr>
+          <a:xfrm>
+            <a:off x="1188720" y="7909560"/>
+            <a:ext cx="5669280" cy="3886200"/>
           </a:xfrm>
           <a:prstGeom prst="rect">
             <a:avLst/>
@@ -1281,15 +1321,15 @@
               <a:buNone/>
             </a:pPr>
             <a:r>
-              <a:rPr lang="en-US" sz="2200" dirty="0">
-                <a:solidFill>
-                  <a:srgbClr val="252525"/>
+              <a:rPr lang="en-US" sz="2200" i="1" dirty="0">
+                <a:solidFill>
+                  <a:srgbClr val="52606D"/>
                 </a:solidFill>
                 <a:latin typeface="Open Sans" pitchFamily="34" charset="0"/>
                 <a:ea typeface="Open Sans" pitchFamily="34" charset="-122"/>
                 <a:cs typeface="Open Sans" pitchFamily="34" charset="-120"/>
               </a:rPr>
-              <a:t>[ The single question this study set out to answer. ]</a:t>
+              <a:t>1–2 sentences: the clinical problem, why it matters, and how common it is — then the gap your study fills.</a:t>
             </a:r>
             <a:endParaRPr lang="en-US" sz="2200" dirty="0"/>
           </a:p>
@@ -1297,14 +1337,14 @@
       </p:sp>
       <p:sp>
         <p:nvSpPr>
-          <p:cNvPr id="14" name="Text 10"/>
-          <p:cNvSpPr/>
-          <p:nvPr/>
-        </p:nvSpPr>
-        <p:spPr>
-          <a:xfrm>
-            <a:off x="822960" y="13990320"/>
-            <a:ext cx="6400800" cy="548640"/>
+          <p:cNvPr id="16" name="Text 12"/>
+          <p:cNvSpPr/>
+          <p:nvPr/>
+        </p:nvSpPr>
+        <p:spPr>
+          <a:xfrm>
+            <a:off x="822960" y="12591288"/>
+            <a:ext cx="6400800" cy="502920"/>
           </a:xfrm>
           <a:prstGeom prst="rect">
             <a:avLst/>
@@ -1328,7 +1368,7 @@
                 <a:ea typeface="Montserrat" pitchFamily="34" charset="-122"/>
                 <a:cs typeface="Montserrat" pitchFamily="34" charset="-120"/>
               </a:rPr>
-              <a:t>Methods</a:t>
+              <a:t>Aim</a:t>
             </a:r>
             <a:endParaRPr lang="en-US" sz="3000" dirty="0"/>
           </a:p>
@@ -1336,18 +1376,41 @@
       </p:sp>
       <p:sp>
         <p:nvSpPr>
-          <p:cNvPr id="15" name="Shape 11"/>
-          <p:cNvSpPr/>
-          <p:nvPr/>
-        </p:nvSpPr>
-        <p:spPr>
-          <a:xfrm>
-            <a:off x="822960" y="14676120"/>
-            <a:ext cx="6400800" cy="5486400"/>
+          <p:cNvPr id="17" name="Shape 13"/>
+          <p:cNvSpPr/>
+          <p:nvPr/>
+        </p:nvSpPr>
+        <p:spPr>
+          <a:xfrm>
+            <a:off x="822960" y="13176504"/>
+            <a:ext cx="2011680" cy="0"/>
+          </a:xfrm>
+          <a:prstGeom prst="line">
+            <a:avLst/>
+          </a:prstGeom>
+          <a:noFill/>
+          <a:ln w="38100">
+            <a:solidFill>
+              <a:srgbClr val="C8102E"/>
+            </a:solidFill>
+            <a:prstDash val="solid"/>
+          </a:ln>
+        </p:spPr>
+      </p:sp>
+      <p:sp>
+        <p:nvSpPr>
+          <p:cNvPr id="18" name="Shape 14"/>
+          <p:cNvSpPr/>
+          <p:nvPr/>
+        </p:nvSpPr>
+        <p:spPr>
+          <a:xfrm>
+            <a:off x="822960" y="13341096"/>
+            <a:ext cx="6400800" cy="2560320"/>
           </a:xfrm>
           <a:prstGeom prst="roundRect">
             <a:avLst>
-              <a:gd name="adj" fmla="val 833"/>
+              <a:gd name="adj" fmla="val 1786"/>
             </a:avLst>
           </a:prstGeom>
           <a:solidFill>
@@ -1363,14 +1426,145 @@
       </p:sp>
       <p:sp>
         <p:nvSpPr>
-          <p:cNvPr id="16" name="Text 12"/>
-          <p:cNvSpPr/>
-          <p:nvPr/>
-        </p:nvSpPr>
-        <p:spPr>
-          <a:xfrm>
-            <a:off x="1143000" y="14950440"/>
-            <a:ext cx="5760720" cy="4937760"/>
+          <p:cNvPr id="19" name="Text 15"/>
+          <p:cNvSpPr/>
+          <p:nvPr/>
+        </p:nvSpPr>
+        <p:spPr>
+          <a:xfrm>
+            <a:off x="1188720" y="13597128"/>
+            <a:ext cx="5669280" cy="2057400"/>
+          </a:xfrm>
+          <a:prstGeom prst="rect">
+            <a:avLst/>
+          </a:prstGeom>
+          <a:noFill/>
+          <a:ln/>
+        </p:spPr>
+        <p:txBody>
+          <a:bodyPr wrap="square" rtlCol="0" anchor="t"/>
+          <a:lstStyle/>
+          <a:p>
+            <a:pPr indent="0" marL="0">
+              <a:lnSpc>
+                <a:spcPct val="130000"/>
+              </a:lnSpc>
+              <a:buNone/>
+            </a:pPr>
+            <a:r>
+              <a:rPr lang="en-US" sz="2200" i="1" dirty="0">
+                <a:solidFill>
+                  <a:srgbClr val="52606D"/>
+                </a:solidFill>
+                <a:latin typeface="Open Sans" pitchFamily="34" charset="0"/>
+                <a:ea typeface="Open Sans" pitchFamily="34" charset="-122"/>
+                <a:cs typeface="Open Sans" pitchFamily="34" charset="-120"/>
+              </a:rPr>
+              <a:t>One sentence: the single, specific, answerable question or objective.</a:t>
+            </a:r>
+            <a:endParaRPr lang="en-US" sz="2200" dirty="0"/>
+          </a:p>
+        </p:txBody>
+      </p:sp>
+      <p:sp>
+        <p:nvSpPr>
+          <p:cNvPr id="20" name="Text 16"/>
+          <p:cNvSpPr/>
+          <p:nvPr/>
+        </p:nvSpPr>
+        <p:spPr>
+          <a:xfrm>
+            <a:off x="822960" y="16450056"/>
+            <a:ext cx="6400800" cy="502920"/>
+          </a:xfrm>
+          <a:prstGeom prst="rect">
+            <a:avLst/>
+          </a:prstGeom>
+          <a:noFill/>
+          <a:ln/>
+        </p:spPr>
+        <p:txBody>
+          <a:bodyPr wrap="square" rtlCol="0" anchor="ctr"/>
+          <a:lstStyle/>
+          <a:p>
+            <a:pPr indent="0" marL="0">
+              <a:buNone/>
+            </a:pPr>
+            <a:r>
+              <a:rPr lang="en-US" sz="3000" b="1" dirty="0">
+                <a:solidFill>
+                  <a:srgbClr val="74101F"/>
+                </a:solidFill>
+                <a:latin typeface="Montserrat" pitchFamily="34" charset="0"/>
+                <a:ea typeface="Montserrat" pitchFamily="34" charset="-122"/>
+                <a:cs typeface="Montserrat" pitchFamily="34" charset="-120"/>
+              </a:rPr>
+              <a:t>Methods</a:t>
+            </a:r>
+            <a:endParaRPr lang="en-US" sz="3000" dirty="0"/>
+          </a:p>
+        </p:txBody>
+      </p:sp>
+      <p:sp>
+        <p:nvSpPr>
+          <p:cNvPr id="21" name="Shape 17"/>
+          <p:cNvSpPr/>
+          <p:nvPr/>
+        </p:nvSpPr>
+        <p:spPr>
+          <a:xfrm>
+            <a:off x="822960" y="17035272"/>
+            <a:ext cx="2011680" cy="0"/>
+          </a:xfrm>
+          <a:prstGeom prst="line">
+            <a:avLst/>
+          </a:prstGeom>
+          <a:noFill/>
+          <a:ln w="38100">
+            <a:solidFill>
+              <a:srgbClr val="C8102E"/>
+            </a:solidFill>
+            <a:prstDash val="solid"/>
+          </a:ln>
+        </p:spPr>
+      </p:sp>
+      <p:sp>
+        <p:nvSpPr>
+          <p:cNvPr id="22" name="Shape 18"/>
+          <p:cNvSpPr/>
+          <p:nvPr/>
+        </p:nvSpPr>
+        <p:spPr>
+          <a:xfrm>
+            <a:off x="822960" y="17199864"/>
+            <a:ext cx="6400800" cy="7863840"/>
+          </a:xfrm>
+          <a:prstGeom prst="roundRect">
+            <a:avLst>
+              <a:gd name="adj" fmla="val 714"/>
+            </a:avLst>
+          </a:prstGeom>
+          <a:solidFill>
+            <a:srgbClr val="FFF1F3"/>
+          </a:solidFill>
+          <a:ln w="12700">
+            <a:solidFill>
+              <a:srgbClr val="F2B8C2"/>
+            </a:solidFill>
+            <a:prstDash val="solid"/>
+          </a:ln>
+        </p:spPr>
+      </p:sp>
+      <p:sp>
+        <p:nvSpPr>
+          <p:cNvPr id="23" name="Text 19"/>
+          <p:cNvSpPr/>
+          <p:nvPr/>
+        </p:nvSpPr>
+        <p:spPr>
+          <a:xfrm>
+            <a:off x="1188720" y="17455896"/>
+            <a:ext cx="5669280" cy="7360920"/>
           </a:xfrm>
           <a:prstGeom prst="rect">
             <a:avLst/>
@@ -1398,7 +1592,7 @@
                 <a:ea typeface="Open Sans" pitchFamily="34" charset="-122"/>
                 <a:cs typeface="Open Sans" pitchFamily="34" charset="-120"/>
               </a:rPr>
-              <a:t>[ Design, setting, population. ]</a:t>
+              <a:t>Design, setting and population.</a:t>
             </a:r>
             <a:endParaRPr lang="en-US" sz="2200" dirty="0"/>
           </a:p>
@@ -1419,7 +1613,7 @@
                 <a:ea typeface="Open Sans" pitchFamily="34" charset="-122"/>
                 <a:cs typeface="Open Sans" pitchFamily="34" charset="-120"/>
               </a:rPr>
-              <a:t>[ Data sources / measurements. ]</a:t>
+              <a:t>Data sources and key measurements.</a:t>
             </a:r>
             <a:endParaRPr lang="en-US" sz="2200" dirty="0"/>
           </a:p>
@@ -1440,22 +1634,43 @@
                 <a:ea typeface="Open Sans" pitchFamily="34" charset="-122"/>
                 <a:cs typeface="Open Sans" pitchFamily="34" charset="-120"/>
               </a:rPr>
-              <a:t>[ Analysis. ]</a:t>
+              <a:t>Analysis — and how bias / confounding were handled.</a:t>
             </a:r>
             <a:endParaRPr lang="en-US" sz="2200" dirty="0"/>
           </a:p>
-        </p:txBody>
-      </p:sp>
-      <p:sp>
-        <p:nvSpPr>
-          <p:cNvPr id="17" name="Text 13"/>
-          <p:cNvSpPr/>
-          <p:nvPr/>
-        </p:nvSpPr>
-        <p:spPr>
-          <a:xfrm>
-            <a:off x="7772400" y="4937760"/>
-            <a:ext cx="6400800" cy="548640"/>
+          <a:p>
+            <a:pPr marL="342900" indent="-342900">
+              <a:lnSpc>
+                <a:spcPct val="130000"/>
+              </a:lnSpc>
+              <a:buSzPct val="100000"/>
+              <a:buChar char="•"/>
+            </a:pPr>
+            <a:r>
+              <a:rPr lang="en-US" sz="2200" dirty="0">
+                <a:solidFill>
+                  <a:srgbClr val="252525"/>
+                </a:solidFill>
+                <a:latin typeface="Open Sans" pitchFamily="34" charset="0"/>
+                <a:ea typeface="Open Sans" pitchFamily="34" charset="-122"/>
+                <a:cs typeface="Open Sans" pitchFamily="34" charset="-120"/>
+              </a:rPr>
+              <a:t>Just enough detail to judge validity.</a:t>
+            </a:r>
+            <a:endParaRPr lang="en-US" sz="2200" dirty="0"/>
+          </a:p>
+        </p:txBody>
+      </p:sp>
+      <p:sp>
+        <p:nvSpPr>
+          <p:cNvPr id="24" name="Text 20"/>
+          <p:cNvSpPr/>
+          <p:nvPr/>
+        </p:nvSpPr>
+        <p:spPr>
+          <a:xfrm>
+            <a:off x="7772400" y="6903720"/>
+            <a:ext cx="6400800" cy="502920"/>
           </a:xfrm>
           <a:prstGeom prst="rect">
             <a:avLst/>
@@ -1487,14 +1702,37 @@
       </p:sp>
       <p:sp>
         <p:nvSpPr>
-          <p:cNvPr id="18" name="Shape 14"/>
-          <p:cNvSpPr/>
-          <p:nvPr/>
-        </p:nvSpPr>
-        <p:spPr>
-          <a:xfrm>
-            <a:off x="7772400" y="5623560"/>
-            <a:ext cx="6400800" cy="6583680"/>
+          <p:cNvPr id="25" name="Shape 21"/>
+          <p:cNvSpPr/>
+          <p:nvPr/>
+        </p:nvSpPr>
+        <p:spPr>
+          <a:xfrm>
+            <a:off x="7772400" y="7488936"/>
+            <a:ext cx="2011680" cy="0"/>
+          </a:xfrm>
+          <a:prstGeom prst="line">
+            <a:avLst/>
+          </a:prstGeom>
+          <a:noFill/>
+          <a:ln w="38100">
+            <a:solidFill>
+              <a:srgbClr val="C8102E"/>
+            </a:solidFill>
+            <a:prstDash val="solid"/>
+          </a:ln>
+        </p:spPr>
+      </p:sp>
+      <p:sp>
+        <p:nvSpPr>
+          <p:cNvPr id="26" name="Shape 22"/>
+          <p:cNvSpPr/>
+          <p:nvPr/>
+        </p:nvSpPr>
+        <p:spPr>
+          <a:xfrm>
+            <a:off x="7772400" y="7653528"/>
+            <a:ext cx="6400800" cy="8961120"/>
           </a:xfrm>
           <a:prstGeom prst="roundRect">
             <a:avLst>
@@ -1514,14 +1752,14 @@
       </p:sp>
       <p:sp>
         <p:nvSpPr>
-          <p:cNvPr id="19" name="Text 15"/>
-          <p:cNvSpPr/>
-          <p:nvPr/>
-        </p:nvSpPr>
-        <p:spPr>
-          <a:xfrm>
-            <a:off x="7772400" y="5623560"/>
-            <a:ext cx="6400800" cy="6583680"/>
+          <p:cNvPr id="27" name="Text 23"/>
+          <p:cNvSpPr/>
+          <p:nvPr/>
+        </p:nvSpPr>
+        <p:spPr>
+          <a:xfrm>
+            <a:off x="8229600" y="7653528"/>
+            <a:ext cx="5486400" cy="8961120"/>
           </a:xfrm>
           <a:prstGeom prst="rect">
             <a:avLst/>
@@ -1534,10 +1772,13 @@
           <a:lstStyle/>
           <a:p>
             <a:pPr algn="ctr" indent="0" marL="0">
+              <a:lnSpc>
+                <a:spcPct val="130000"/>
+              </a:lnSpc>
               <a:buNone/>
             </a:pPr>
             <a:r>
-              <a:rPr lang="en-US" sz="2000" dirty="0">
+              <a:rPr lang="en-US" sz="2000" i="1" dirty="0">
                 <a:solidFill>
                   <a:srgbClr val="52606D"/>
                 </a:solidFill>
@@ -1545,26 +1786,95 @@
                 <a:ea typeface="Open Sans" pitchFamily="34" charset="-122"/>
                 <a:cs typeface="Open Sans" pitchFamily="34" charset="-120"/>
               </a:rPr>
-              <a:t>[ Figure 1 — paste your chart or image ]</a:t>
+              <a:t>Your main figure or table.</a:t>
             </a:r>
             <a:endParaRPr lang="en-US" sz="2000" dirty="0"/>
           </a:p>
-        </p:txBody>
-      </p:sp>
-      <p:sp>
-        <p:nvSpPr>
-          <p:cNvPr id="20" name="Shape 16"/>
-          <p:cNvSpPr/>
-          <p:nvPr/>
-        </p:nvSpPr>
-        <p:spPr>
-          <a:xfrm>
-            <a:off x="7772400" y="12664440"/>
-            <a:ext cx="6400800" cy="5669280"/>
+          <a:p>
+            <a:pPr algn="ctr" indent="0" marL="0">
+              <a:lnSpc>
+                <a:spcPct val="130000"/>
+              </a:lnSpc>
+              <a:buNone/>
+            </a:pPr>
+            <a:endParaRPr lang="en-US" sz="2000" dirty="0"/>
+          </a:p>
+          <a:p>
+            <a:pPr algn="ctr" indent="0" marL="0">
+              <a:lnSpc>
+                <a:spcPct val="130000"/>
+              </a:lnSpc>
+              <a:buNone/>
+            </a:pPr>
+            <a:r>
+              <a:rPr lang="en-US" sz="2000" i="1" dirty="0">
+                <a:solidFill>
+                  <a:srgbClr val="52606D"/>
+                </a:solidFill>
+                <a:latin typeface="Open Sans" pitchFamily="34" charset="0"/>
+                <a:ea typeface="Open Sans" pitchFamily="34" charset="-122"/>
+                <a:cs typeface="Open Sans" pitchFamily="34" charset="-120"/>
+              </a:rPr>
+              <a:t>Lead with the result, not the method —</a:t>
+            </a:r>
+            <a:endParaRPr lang="en-US" sz="2000" dirty="0"/>
+          </a:p>
+          <a:p>
+            <a:pPr algn="ctr" indent="0" marL="0">
+              <a:lnSpc>
+                <a:spcPct val="130000"/>
+              </a:lnSpc>
+              <a:buNone/>
+            </a:pPr>
+            <a:r>
+              <a:rPr lang="en-US" sz="2000" i="1" dirty="0">
+                <a:solidFill>
+                  <a:srgbClr val="52606D"/>
+                </a:solidFill>
+                <a:latin typeface="Open Sans" pitchFamily="34" charset="0"/>
+                <a:ea typeface="Open Sans" pitchFamily="34" charset="-122"/>
+                <a:cs typeface="Open Sans" pitchFamily="34" charset="-120"/>
+              </a:rPr>
+              <a:t>label the axes and give numbers</a:t>
+            </a:r>
+            <a:endParaRPr lang="en-US" sz="2000" dirty="0"/>
+          </a:p>
+          <a:p>
+            <a:pPr algn="ctr" indent="0" marL="0">
+              <a:lnSpc>
+                <a:spcPct val="130000"/>
+              </a:lnSpc>
+              <a:buNone/>
+            </a:pPr>
+            <a:r>
+              <a:rPr lang="en-US" sz="2000" i="1" dirty="0">
+                <a:solidFill>
+                  <a:srgbClr val="52606D"/>
+                </a:solidFill>
+                <a:latin typeface="Open Sans" pitchFamily="34" charset="0"/>
+                <a:ea typeface="Open Sans" pitchFamily="34" charset="-122"/>
+                <a:cs typeface="Open Sans" pitchFamily="34" charset="-120"/>
+              </a:rPr>
+              <a:t>with 95% confidence intervals.</a:t>
+            </a:r>
+            <a:endParaRPr lang="en-US" sz="2000" dirty="0"/>
+          </a:p>
+        </p:txBody>
+      </p:sp>
+      <p:sp>
+        <p:nvSpPr>
+          <p:cNvPr id="28" name="Shape 24"/>
+          <p:cNvSpPr/>
+          <p:nvPr/>
+        </p:nvSpPr>
+        <p:spPr>
+          <a:xfrm>
+            <a:off x="7772400" y="17071848"/>
+            <a:ext cx="6400800" cy="6035040"/>
           </a:xfrm>
           <a:prstGeom prst="roundRect">
             <a:avLst>
-              <a:gd name="adj" fmla="val 806"/>
+              <a:gd name="adj" fmla="val 758"/>
             </a:avLst>
           </a:prstGeom>
           <a:solidFill>
@@ -1580,14 +1890,14 @@
       </p:sp>
       <p:sp>
         <p:nvSpPr>
-          <p:cNvPr id="21" name="Text 17"/>
-          <p:cNvSpPr/>
-          <p:nvPr/>
-        </p:nvSpPr>
-        <p:spPr>
-          <a:xfrm>
-            <a:off x="7772400" y="12664440"/>
-            <a:ext cx="6400800" cy="5669280"/>
+          <p:cNvPr id="29" name="Text 25"/>
+          <p:cNvSpPr/>
+          <p:nvPr/>
+        </p:nvSpPr>
+        <p:spPr>
+          <a:xfrm>
+            <a:off x="8229600" y="17071848"/>
+            <a:ext cx="5486400" cy="6035040"/>
           </a:xfrm>
           <a:prstGeom prst="rect">
             <a:avLst/>
@@ -1600,118 +1910,60 @@
           <a:lstStyle/>
           <a:p>
             <a:pPr algn="ctr" indent="0" marL="0">
-              <a:buNone/>
-            </a:pPr>
-            <a:r>
-              <a:rPr lang="en-US" sz="2000" dirty="0">
-                <a:solidFill>
-                  <a:srgbClr val="52606D"/>
-                </a:solidFill>
-                <a:latin typeface="Open Sans" pitchFamily="34" charset="0"/>
-                <a:ea typeface="Open Sans" pitchFamily="34" charset="-122"/>
-                <a:cs typeface="Open Sans" pitchFamily="34" charset="-120"/>
-              </a:rPr>
-              <a:t>[ Table 1 / Figure 2 ]</a:t>
-            </a:r>
-            <a:endParaRPr lang="en-US" sz="2000" dirty="0"/>
-          </a:p>
-        </p:txBody>
-      </p:sp>
-      <p:sp>
-        <p:nvSpPr>
-          <p:cNvPr id="22" name="Text 18"/>
-          <p:cNvSpPr/>
-          <p:nvPr/>
-        </p:nvSpPr>
-        <p:spPr>
-          <a:xfrm>
-            <a:off x="7772400" y="18790920"/>
-            <a:ext cx="6400800" cy="1280160"/>
-          </a:xfrm>
-          <a:prstGeom prst="rect">
-            <a:avLst/>
-          </a:prstGeom>
-          <a:noFill/>
-          <a:ln/>
-        </p:spPr>
-        <p:txBody>
-          <a:bodyPr wrap="square" rtlCol="0" anchor="t"/>
-          <a:lstStyle/>
-          <a:p>
-            <a:pPr indent="0" marL="0">
               <a:lnSpc>
                 <a:spcPct val="130000"/>
               </a:lnSpc>
               <a:buNone/>
             </a:pPr>
             <a:r>
-              <a:rPr lang="en-US" sz="2200" dirty="0">
-                <a:solidFill>
-                  <a:srgbClr val="252525"/>
+              <a:rPr lang="en-US" sz="2000" i="1" dirty="0">
+                <a:solidFill>
+                  <a:srgbClr val="52606D"/>
                 </a:solidFill>
                 <a:latin typeface="Open Sans" pitchFamily="34" charset="0"/>
                 <a:ea typeface="Open Sans" pitchFamily="34" charset="-122"/>
                 <a:cs typeface="Open Sans" pitchFamily="34" charset="-120"/>
               </a:rPr>
-              <a:t>[ One or two sentences highlighting the key finding. ]</a:t>
-            </a:r>
-            <a:endParaRPr lang="en-US" sz="2200" dirty="0"/>
-          </a:p>
-        </p:txBody>
-      </p:sp>
-      <p:sp>
-        <p:nvSpPr>
-          <p:cNvPr id="23" name="Text 19"/>
-          <p:cNvSpPr/>
-          <p:nvPr/>
-        </p:nvSpPr>
-        <p:spPr>
-          <a:xfrm>
-            <a:off x="14721840" y="4937760"/>
-            <a:ext cx="6400800" cy="548640"/>
-          </a:xfrm>
-          <a:prstGeom prst="rect">
-            <a:avLst/>
-          </a:prstGeom>
-          <a:noFill/>
-          <a:ln/>
-        </p:spPr>
-        <p:txBody>
-          <a:bodyPr wrap="square" rtlCol="0" anchor="ctr"/>
-          <a:lstStyle/>
-          <a:p>
-            <a:pPr indent="0" marL="0">
+              <a:t>A second figure or a key table —</a:t>
+            </a:r>
+            <a:endParaRPr lang="en-US" sz="2000" dirty="0"/>
+          </a:p>
+          <a:p>
+            <a:pPr algn="ctr" indent="0" marL="0">
+              <a:lnSpc>
+                <a:spcPct val="130000"/>
+              </a:lnSpc>
               <a:buNone/>
             </a:pPr>
             <a:r>
-              <a:rPr lang="en-US" sz="3000" b="1" dirty="0">
-                <a:solidFill>
-                  <a:srgbClr val="74101F"/>
-                </a:solidFill>
-                <a:latin typeface="Montserrat" pitchFamily="34" charset="0"/>
-                <a:ea typeface="Montserrat" pitchFamily="34" charset="-122"/>
-                <a:cs typeface="Montserrat" pitchFamily="34" charset="-120"/>
-              </a:rPr>
-              <a:t>Conclusions &amp; interpretation</a:t>
-            </a:r>
-            <a:endParaRPr lang="en-US" sz="3000" dirty="0"/>
-          </a:p>
-        </p:txBody>
-      </p:sp>
-      <p:sp>
-        <p:nvSpPr>
-          <p:cNvPr id="24" name="Shape 20"/>
-          <p:cNvSpPr/>
-          <p:nvPr/>
-        </p:nvSpPr>
-        <p:spPr>
-          <a:xfrm>
-            <a:off x="14721840" y="5623560"/>
-            <a:ext cx="6400800" cy="5486400"/>
+              <a:rPr lang="en-US" sz="2000" i="1" dirty="0">
+                <a:solidFill>
+                  <a:srgbClr val="52606D"/>
+                </a:solidFill>
+                <a:latin typeface="Open Sans" pitchFamily="34" charset="0"/>
+                <a:ea typeface="Open Sans" pitchFamily="34" charset="-122"/>
+                <a:cs typeface="Open Sans" pitchFamily="34" charset="-120"/>
+              </a:rPr>
+              <a:t>only if it adds something new.</a:t>
+            </a:r>
+            <a:endParaRPr lang="en-US" sz="2000" dirty="0"/>
+          </a:p>
+        </p:txBody>
+      </p:sp>
+      <p:sp>
+        <p:nvSpPr>
+          <p:cNvPr id="30" name="Shape 26"/>
+          <p:cNvSpPr/>
+          <p:nvPr/>
+        </p:nvSpPr>
+        <p:spPr>
+          <a:xfrm>
+            <a:off x="7772400" y="23564088"/>
+            <a:ext cx="6400800" cy="2377440"/>
           </a:xfrm>
           <a:prstGeom prst="roundRect">
             <a:avLst>
-              <a:gd name="adj" fmla="val 833"/>
+              <a:gd name="adj" fmla="val 1923"/>
             </a:avLst>
           </a:prstGeom>
           <a:solidFill>
@@ -1727,14 +1979,14 @@
       </p:sp>
       <p:sp>
         <p:nvSpPr>
-          <p:cNvPr id="25" name="Text 21"/>
-          <p:cNvSpPr/>
-          <p:nvPr/>
-        </p:nvSpPr>
-        <p:spPr>
-          <a:xfrm>
-            <a:off x="15041880" y="5897880"/>
-            <a:ext cx="5760720" cy="4937760"/>
+          <p:cNvPr id="31" name="Text 27"/>
+          <p:cNvSpPr/>
+          <p:nvPr/>
+        </p:nvSpPr>
+        <p:spPr>
+          <a:xfrm>
+            <a:off x="8138160" y="23838408"/>
+            <a:ext cx="5669280" cy="1828800"/>
           </a:xfrm>
           <a:prstGeom prst="rect">
             <a:avLst/>
@@ -1753,15 +2005,32 @@
               <a:buNone/>
             </a:pPr>
             <a:r>
-              <a:rPr lang="en-US" sz="2200" dirty="0">
-                <a:solidFill>
-                  <a:srgbClr val="252525"/>
+              <a:rPr lang="en-US" sz="2200" b="1" dirty="0">
+                <a:solidFill>
+                  <a:srgbClr val="74101F"/>
                 </a:solidFill>
                 <a:latin typeface="Open Sans" pitchFamily="34" charset="0"/>
                 <a:ea typeface="Open Sans" pitchFamily="34" charset="-122"/>
                 <a:cs typeface="Open Sans" pitchFamily="34" charset="-120"/>
               </a:rPr>
-              <a:t>[ Main finding · what it means · implication for Nordic lung-cancer care or research. ]</a:t>
+              <a:t>Key numbers — </a:t>
+            </a:r>
+            <a:pPr indent="0" marL="0">
+              <a:lnSpc>
+                <a:spcPct val="130000"/>
+              </a:lnSpc>
+              <a:buNone/>
+            </a:pPr>
+            <a:r>
+              <a:rPr lang="en-US" sz="2200" i="1" dirty="0">
+                <a:solidFill>
+                  <a:srgbClr val="52606D"/>
+                </a:solidFill>
+                <a:latin typeface="Open Sans" pitchFamily="34" charset="0"/>
+                <a:ea typeface="Open Sans" pitchFamily="34" charset="-122"/>
+                <a:cs typeface="Open Sans" pitchFamily="34" charset="-120"/>
+              </a:rPr>
+              <a:t>report effect sizes with confidence intervals, not p-values alone.</a:t>
             </a:r>
             <a:endParaRPr lang="en-US" sz="2200" dirty="0"/>
           </a:p>
@@ -1769,14 +2038,14 @@
       </p:sp>
       <p:sp>
         <p:nvSpPr>
-          <p:cNvPr id="26" name="Text 22"/>
-          <p:cNvSpPr/>
-          <p:nvPr/>
-        </p:nvSpPr>
-        <p:spPr>
-          <a:xfrm>
-            <a:off x="14721840" y="11750040"/>
-            <a:ext cx="6400800" cy="548640"/>
+          <p:cNvPr id="32" name="Text 28"/>
+          <p:cNvSpPr/>
+          <p:nvPr/>
+        </p:nvSpPr>
+        <p:spPr>
+          <a:xfrm>
+            <a:off x="14721840" y="6903720"/>
+            <a:ext cx="6400800" cy="502920"/>
           </a:xfrm>
           <a:prstGeom prst="rect">
             <a:avLst/>
@@ -1800,7 +2069,7 @@
                 <a:ea typeface="Montserrat" pitchFamily="34" charset="-122"/>
                 <a:cs typeface="Montserrat" pitchFamily="34" charset="-120"/>
               </a:rPr>
-              <a:t>References</a:t>
+              <a:t>Conclusions &amp; interpretation</a:t>
             </a:r>
             <a:endParaRPr lang="en-US" sz="3000" dirty="0"/>
           </a:p>
@@ -1808,18 +2077,41 @@
       </p:sp>
       <p:sp>
         <p:nvSpPr>
-          <p:cNvPr id="27" name="Shape 23"/>
-          <p:cNvSpPr/>
-          <p:nvPr/>
-        </p:nvSpPr>
-        <p:spPr>
-          <a:xfrm>
-            <a:off x="14721840" y="12435840"/>
-            <a:ext cx="6400800" cy="3657600"/>
+          <p:cNvPr id="33" name="Shape 29"/>
+          <p:cNvSpPr/>
+          <p:nvPr/>
+        </p:nvSpPr>
+        <p:spPr>
+          <a:xfrm>
+            <a:off x="14721840" y="7488936"/>
+            <a:ext cx="2011680" cy="0"/>
+          </a:xfrm>
+          <a:prstGeom prst="line">
+            <a:avLst/>
+          </a:prstGeom>
+          <a:noFill/>
+          <a:ln w="38100">
+            <a:solidFill>
+              <a:srgbClr val="C8102E"/>
+            </a:solidFill>
+            <a:prstDash val="solid"/>
+          </a:ln>
+        </p:spPr>
+      </p:sp>
+      <p:sp>
+        <p:nvSpPr>
+          <p:cNvPr id="34" name="Shape 30"/>
+          <p:cNvSpPr/>
+          <p:nvPr/>
+        </p:nvSpPr>
+        <p:spPr>
+          <a:xfrm>
+            <a:off x="14721840" y="7653528"/>
+            <a:ext cx="6400800" cy="6400800"/>
           </a:xfrm>
           <a:prstGeom prst="roundRect">
             <a:avLst>
-              <a:gd name="adj" fmla="val 1250"/>
+              <a:gd name="adj" fmla="val 714"/>
             </a:avLst>
           </a:prstGeom>
           <a:solidFill>
@@ -1835,14 +2127,14 @@
       </p:sp>
       <p:sp>
         <p:nvSpPr>
-          <p:cNvPr id="28" name="Text 24"/>
-          <p:cNvSpPr/>
-          <p:nvPr/>
-        </p:nvSpPr>
-        <p:spPr>
-          <a:xfrm>
-            <a:off x="15041880" y="12710160"/>
-            <a:ext cx="5760720" cy="3108960"/>
+          <p:cNvPr id="35" name="Text 31"/>
+          <p:cNvSpPr/>
+          <p:nvPr/>
+        </p:nvSpPr>
+        <p:spPr>
+          <a:xfrm>
+            <a:off x="15087600" y="7909560"/>
+            <a:ext cx="5669280" cy="5897880"/>
           </a:xfrm>
           <a:prstGeom prst="rect">
             <a:avLst/>
@@ -1861,70 +2153,30 @@
               <a:buNone/>
             </a:pPr>
             <a:r>
-              <a:rPr lang="en-US" sz="2200" dirty="0">
-                <a:solidFill>
-                  <a:srgbClr val="252525"/>
+              <a:rPr lang="en-US" sz="2200" i="1" dirty="0">
+                <a:solidFill>
+                  <a:srgbClr val="52606D"/>
                 </a:solidFill>
                 <a:latin typeface="Open Sans" pitchFamily="34" charset="0"/>
                 <a:ea typeface="Open Sans" pitchFamily="34" charset="-122"/>
                 <a:cs typeface="Open Sans" pitchFamily="34" charset="-120"/>
               </a:rPr>
-              <a:t>[ 1. … ]</a:t>
+              <a:t>What the main finding means · one honest limitation · the implication for Nordic lung-cancer practice or research. Don’t overclaim.</a:t>
             </a:r>
             <a:endParaRPr lang="en-US" sz="2200" dirty="0"/>
           </a:p>
-          <a:p>
-            <a:pPr indent="0" marL="0">
-              <a:lnSpc>
-                <a:spcPct val="130000"/>
-              </a:lnSpc>
-              <a:buNone/>
-            </a:pPr>
-            <a:r>
-              <a:rPr lang="en-US" sz="2200" dirty="0">
-                <a:solidFill>
-                  <a:srgbClr val="252525"/>
-                </a:solidFill>
-                <a:latin typeface="Open Sans" pitchFamily="34" charset="0"/>
-                <a:ea typeface="Open Sans" pitchFamily="34" charset="-122"/>
-                <a:cs typeface="Open Sans" pitchFamily="34" charset="-120"/>
-              </a:rPr>
-              <a:t>[ 2. … ]</a:t>
-            </a:r>
-            <a:endParaRPr lang="en-US" sz="2200" dirty="0"/>
-          </a:p>
-          <a:p>
-            <a:pPr indent="0" marL="0">
-              <a:lnSpc>
-                <a:spcPct val="130000"/>
-              </a:lnSpc>
-              <a:buNone/>
-            </a:pPr>
-            <a:r>
-              <a:rPr lang="en-US" sz="2200" dirty="0">
-                <a:solidFill>
-                  <a:srgbClr val="252525"/>
-                </a:solidFill>
-                <a:latin typeface="Open Sans" pitchFamily="34" charset="0"/>
-                <a:ea typeface="Open Sans" pitchFamily="34" charset="-122"/>
-                <a:cs typeface="Open Sans" pitchFamily="34" charset="-120"/>
-              </a:rPr>
-              <a:t>[ 3. … ]</a:t>
-            </a:r>
-            <a:endParaRPr lang="en-US" sz="2200" dirty="0"/>
-          </a:p>
-        </p:txBody>
-      </p:sp>
-      <p:sp>
-        <p:nvSpPr>
-          <p:cNvPr id="29" name="Text 25"/>
-          <p:cNvSpPr/>
-          <p:nvPr/>
-        </p:nvSpPr>
-        <p:spPr>
-          <a:xfrm>
-            <a:off x="14721840" y="16733520"/>
-            <a:ext cx="6400800" cy="548640"/>
+        </p:txBody>
+      </p:sp>
+      <p:sp>
+        <p:nvSpPr>
+          <p:cNvPr id="36" name="Text 32"/>
+          <p:cNvSpPr/>
+          <p:nvPr/>
+        </p:nvSpPr>
+        <p:spPr>
+          <a:xfrm>
+            <a:off x="14721840" y="14602968"/>
+            <a:ext cx="6400800" cy="502920"/>
           </a:xfrm>
           <a:prstGeom prst="rect">
             <a:avLst/>
@@ -1948,7 +2200,7 @@
                 <a:ea typeface="Montserrat" pitchFamily="34" charset="-122"/>
                 <a:cs typeface="Montserrat" pitchFamily="34" charset="-120"/>
               </a:rPr>
-              <a:t>Acknowledgements &amp; funding</a:t>
+              <a:t>References</a:t>
             </a:r>
             <a:endParaRPr lang="en-US" sz="3000" dirty="0"/>
           </a:p>
@@ -1956,18 +2208,41 @@
       </p:sp>
       <p:sp>
         <p:nvSpPr>
-          <p:cNvPr id="30" name="Shape 26"/>
-          <p:cNvSpPr/>
-          <p:nvPr/>
-        </p:nvSpPr>
-        <p:spPr>
-          <a:xfrm>
-            <a:off x="14721840" y="17419320"/>
-            <a:ext cx="6400800" cy="2743200"/>
+          <p:cNvPr id="37" name="Shape 33"/>
+          <p:cNvSpPr/>
+          <p:nvPr/>
+        </p:nvSpPr>
+        <p:spPr>
+          <a:xfrm>
+            <a:off x="14721840" y="15188184"/>
+            <a:ext cx="2011680" cy="0"/>
+          </a:xfrm>
+          <a:prstGeom prst="line">
+            <a:avLst/>
+          </a:prstGeom>
+          <a:noFill/>
+          <a:ln w="38100">
+            <a:solidFill>
+              <a:srgbClr val="C8102E"/>
+            </a:solidFill>
+            <a:prstDash val="solid"/>
+          </a:ln>
+        </p:spPr>
+      </p:sp>
+      <p:sp>
+        <p:nvSpPr>
+          <p:cNvPr id="38" name="Shape 34"/>
+          <p:cNvSpPr/>
+          <p:nvPr/>
+        </p:nvSpPr>
+        <p:spPr>
+          <a:xfrm>
+            <a:off x="14721840" y="15352776"/>
+            <a:ext cx="6400800" cy="4023360"/>
           </a:xfrm>
           <a:prstGeom prst="roundRect">
             <a:avLst>
-              <a:gd name="adj" fmla="val 1667"/>
+              <a:gd name="adj" fmla="val 1136"/>
             </a:avLst>
           </a:prstGeom>
           <a:solidFill>
@@ -1983,14 +2258,14 @@
       </p:sp>
       <p:sp>
         <p:nvSpPr>
-          <p:cNvPr id="31" name="Text 27"/>
-          <p:cNvSpPr/>
-          <p:nvPr/>
-        </p:nvSpPr>
-        <p:spPr>
-          <a:xfrm>
-            <a:off x="15041880" y="17693640"/>
-            <a:ext cx="5760720" cy="2194560"/>
+          <p:cNvPr id="39" name="Text 35"/>
+          <p:cNvSpPr/>
+          <p:nvPr/>
+        </p:nvSpPr>
+        <p:spPr>
+          <a:xfrm>
+            <a:off x="15087600" y="15608808"/>
+            <a:ext cx="5669280" cy="3520440"/>
           </a:xfrm>
           <a:prstGeom prst="rect">
             <a:avLst/>
@@ -2009,15 +2284,15 @@
               <a:buNone/>
             </a:pPr>
             <a:r>
-              <a:rPr lang="en-US" sz="2200" dirty="0">
-                <a:solidFill>
-                  <a:srgbClr val="252525"/>
+              <a:rPr lang="en-US" sz="2200" i="1" dirty="0">
+                <a:solidFill>
+                  <a:srgbClr val="52606D"/>
                 </a:solidFill>
                 <a:latin typeface="Open Sans" pitchFamily="34" charset="0"/>
                 <a:ea typeface="Open Sans" pitchFamily="34" charset="-122"/>
                 <a:cs typeface="Open Sans" pitchFamily="34" charset="-120"/>
               </a:rPr>
-              <a:t>[ Funding sources, collaborators, contact. ]</a:t>
+              <a:t>3–5 key references, Vancouver style.</a:t>
             </a:r>
             <a:endParaRPr lang="en-US" sz="2200" dirty="0"/>
           </a:p>
@@ -2025,14 +2300,145 @@
       </p:sp>
       <p:sp>
         <p:nvSpPr>
-          <p:cNvPr id="32" name="Shape 28"/>
-          <p:cNvSpPr/>
-          <p:nvPr/>
-        </p:nvSpPr>
-        <p:spPr>
-          <a:xfrm>
-            <a:off x="0" y="28986480"/>
-            <a:ext cx="21387816" cy="1289304"/>
+          <p:cNvPr id="40" name="Text 36"/>
+          <p:cNvSpPr/>
+          <p:nvPr/>
+        </p:nvSpPr>
+        <p:spPr>
+          <a:xfrm>
+            <a:off x="14721840" y="19924776"/>
+            <a:ext cx="6400800" cy="502920"/>
+          </a:xfrm>
+          <a:prstGeom prst="rect">
+            <a:avLst/>
+          </a:prstGeom>
+          <a:noFill/>
+          <a:ln/>
+        </p:spPr>
+        <p:txBody>
+          <a:bodyPr wrap="square" rtlCol="0" anchor="ctr"/>
+          <a:lstStyle/>
+          <a:p>
+            <a:pPr indent="0" marL="0">
+              <a:buNone/>
+            </a:pPr>
+            <a:r>
+              <a:rPr lang="en-US" sz="3000" b="1" dirty="0">
+                <a:solidFill>
+                  <a:srgbClr val="74101F"/>
+                </a:solidFill>
+                <a:latin typeface="Montserrat" pitchFamily="34" charset="0"/>
+                <a:ea typeface="Montserrat" pitchFamily="34" charset="-122"/>
+                <a:cs typeface="Montserrat" pitchFamily="34" charset="-120"/>
+              </a:rPr>
+              <a:t>Acknowledgements &amp; funding</a:t>
+            </a:r>
+            <a:endParaRPr lang="en-US" sz="3000" dirty="0"/>
+          </a:p>
+        </p:txBody>
+      </p:sp>
+      <p:sp>
+        <p:nvSpPr>
+          <p:cNvPr id="41" name="Shape 37"/>
+          <p:cNvSpPr/>
+          <p:nvPr/>
+        </p:nvSpPr>
+        <p:spPr>
+          <a:xfrm>
+            <a:off x="14721840" y="20509992"/>
+            <a:ext cx="2011680" cy="0"/>
+          </a:xfrm>
+          <a:prstGeom prst="line">
+            <a:avLst/>
+          </a:prstGeom>
+          <a:noFill/>
+          <a:ln w="38100">
+            <a:solidFill>
+              <a:srgbClr val="C8102E"/>
+            </a:solidFill>
+            <a:prstDash val="solid"/>
+          </a:ln>
+        </p:spPr>
+      </p:sp>
+      <p:sp>
+        <p:nvSpPr>
+          <p:cNvPr id="42" name="Shape 38"/>
+          <p:cNvSpPr/>
+          <p:nvPr/>
+        </p:nvSpPr>
+        <p:spPr>
+          <a:xfrm>
+            <a:off x="14721840" y="20674584"/>
+            <a:ext cx="6400800" cy="3840480"/>
+          </a:xfrm>
+          <a:prstGeom prst="roundRect">
+            <a:avLst>
+              <a:gd name="adj" fmla="val 1190"/>
+            </a:avLst>
+          </a:prstGeom>
+          <a:solidFill>
+            <a:srgbClr val="FFF1F3"/>
+          </a:solidFill>
+          <a:ln w="12700">
+            <a:solidFill>
+              <a:srgbClr val="F2B8C2"/>
+            </a:solidFill>
+            <a:prstDash val="solid"/>
+          </a:ln>
+        </p:spPr>
+      </p:sp>
+      <p:sp>
+        <p:nvSpPr>
+          <p:cNvPr id="43" name="Text 39"/>
+          <p:cNvSpPr/>
+          <p:nvPr/>
+        </p:nvSpPr>
+        <p:spPr>
+          <a:xfrm>
+            <a:off x="15087600" y="20930616"/>
+            <a:ext cx="5669280" cy="3337560"/>
+          </a:xfrm>
+          <a:prstGeom prst="rect">
+            <a:avLst/>
+          </a:prstGeom>
+          <a:noFill/>
+          <a:ln/>
+        </p:spPr>
+        <p:txBody>
+          <a:bodyPr wrap="square" rtlCol="0" anchor="t"/>
+          <a:lstStyle/>
+          <a:p>
+            <a:pPr indent="0" marL="0">
+              <a:lnSpc>
+                <a:spcPct val="130000"/>
+              </a:lnSpc>
+              <a:buNone/>
+            </a:pPr>
+            <a:r>
+              <a:rPr lang="en-US" sz="2200" i="1" dirty="0">
+                <a:solidFill>
+                  <a:srgbClr val="52606D"/>
+                </a:solidFill>
+                <a:latin typeface="Open Sans" pitchFamily="34" charset="0"/>
+                <a:ea typeface="Open Sans" pitchFamily="34" charset="-122"/>
+                <a:cs typeface="Open Sans" pitchFamily="34" charset="-120"/>
+              </a:rPr>
+              <a:t>Funding sources, collaborators, and a contact email.</a:t>
+            </a:r>
+            <a:endParaRPr lang="en-US" sz="2200" dirty="0"/>
+          </a:p>
+        </p:txBody>
+      </p:sp>
+      <p:sp>
+        <p:nvSpPr>
+          <p:cNvPr id="44" name="Shape 40"/>
+          <p:cNvSpPr/>
+          <p:nvPr/>
+        </p:nvSpPr>
+        <p:spPr>
+          <a:xfrm>
+            <a:off x="0" y="28803600"/>
+            <a:ext cx="21387816" cy="1472184"/>
           </a:xfrm>
           <a:prstGeom prst="rect">
             <a:avLst/>
@@ -2045,7 +2451,7 @@
       </p:sp>
       <p:pic>
         <p:nvPicPr>
-          <p:cNvPr id="33" name="Image 2" descr="/Users/heidiandersen/ntog/ntog-logo-1024.png">    </p:cNvPr>
+          <p:cNvPr id="45" name="Image 2" descr="/Users/heidiandersen/ntog/ntog-logo-1024.png">    </p:cNvPr>
           <p:cNvPicPr>
             <a:picLocks noChangeAspect="1"/>
           </p:cNvPicPr>
@@ -2059,8 +2465,8 @@
         </p:blipFill>
         <p:spPr>
           <a:xfrm>
-            <a:off x="822960" y="29215080"/>
-            <a:ext cx="822960" cy="822960"/>
+            <a:off x="822960" y="29059632"/>
+            <a:ext cx="960120" cy="960120"/>
           </a:xfrm>
           <a:prstGeom prst="rect">
             <a:avLst/>
@@ -2069,14 +2475,14 @@
       </p:pic>
       <p:sp>
         <p:nvSpPr>
-          <p:cNvPr id="34" name="Text 29"/>
-          <p:cNvSpPr/>
-          <p:nvPr/>
-        </p:nvSpPr>
-        <p:spPr>
-          <a:xfrm>
-            <a:off x="1920240" y="28986480"/>
-            <a:ext cx="18653760" cy="1289304"/>
+          <p:cNvPr id="46" name="Text 41"/>
+          <p:cNvSpPr/>
+          <p:nvPr/>
+        </p:nvSpPr>
+        <p:spPr>
+          <a:xfrm>
+            <a:off x="2103120" y="28803600"/>
+            <a:ext cx="18470880" cy="1472184"/>
           </a:xfrm>
           <a:prstGeom prst="rect">
             <a:avLst/>
@@ -2100,7 +2506,7 @@
                 <a:ea typeface="Montserrat" pitchFamily="34" charset="-122"/>
                 <a:cs typeface="Montserrat" pitchFamily="34" charset="-120"/>
               </a:rPr>
-              <a:t>Contact: [ email@institution ]      ntog.org/ntog2027      #NLCS2027</a:t>
+              <a:t>Contact: [ email@institution ]      ·      ntog.org/ntog2027      ·      #NLCS2027</a:t>
             </a:r>
             <a:endParaRPr lang="en-US" sz="2000" dirty="0"/>
           </a:p>

</xml_diff>

<commit_message>
A1 poster: remove under-heading accent lines; balance cards to fill A1
Applying the pptx skill's guidance and a real visual QA pass (LibreOffice now
available to render):
- Remove the red rules under section headings (an AI-generated-slide tell);
  rely on whitespace + heading weight for hierarchy.
- Enlarge cards and result figures so the three columns fill the A1 height
  evenly instead of leaving ~3-4 in of empty space at the bottom.
Rendered to image and inspected — no overflow, overlap or contrast issues.
Header/footer bands are the requested 2027 brand; pink cards are brand, not a
cream default.

Co-Authored-By: Claude Opus 4.8 <noreply@anthropic.com>
</commit_message>
<xml_diff>
--- a/ntog2027/nlcs2027-poster-A1-template.pptx
+++ b/ntog2027/nlcs2027-poster-A1-template.pptx
@@ -1251,35 +1251,12 @@
         </p:nvSpPr>
         <p:spPr>
           <a:xfrm>
-            <a:off x="822960" y="7488936"/>
-            <a:ext cx="2011680" cy="0"/>
-          </a:xfrm>
-          <a:prstGeom prst="line">
-            <a:avLst/>
-          </a:prstGeom>
-          <a:noFill/>
-          <a:ln w="38100">
-            <a:solidFill>
-              <a:srgbClr val="C8102E"/>
-            </a:solidFill>
-            <a:prstDash val="solid"/>
-          </a:ln>
-        </p:spPr>
-      </p:sp>
-      <p:sp>
-        <p:nvSpPr>
-          <p:cNvPr id="14" name="Shape 10"/>
-          <p:cNvSpPr/>
-          <p:nvPr/>
-        </p:nvSpPr>
-        <p:spPr>
-          <a:xfrm>
             <a:off x="822960" y="7653528"/>
-            <a:ext cx="6400800" cy="4389120"/>
+            <a:ext cx="6400800" cy="4937760"/>
           </a:xfrm>
           <a:prstGeom prst="roundRect">
             <a:avLst>
-              <a:gd name="adj" fmla="val 1042"/>
+              <a:gd name="adj" fmla="val 926"/>
             </a:avLst>
           </a:prstGeom>
           <a:solidFill>
@@ -1295,14 +1272,14 @@
       </p:sp>
       <p:sp>
         <p:nvSpPr>
-          <p:cNvPr id="15" name="Text 11"/>
+          <p:cNvPr id="14" name="Text 10"/>
           <p:cNvSpPr/>
           <p:nvPr/>
         </p:nvSpPr>
         <p:spPr>
           <a:xfrm>
             <a:off x="1188720" y="7909560"/>
-            <a:ext cx="5669280" cy="3886200"/>
+            <a:ext cx="5669280" cy="4434840"/>
           </a:xfrm>
           <a:prstGeom prst="rect">
             <a:avLst/>
@@ -1337,13 +1314,13 @@
       </p:sp>
       <p:sp>
         <p:nvSpPr>
-          <p:cNvPr id="16" name="Text 12"/>
-          <p:cNvSpPr/>
-          <p:nvPr/>
-        </p:nvSpPr>
-        <p:spPr>
-          <a:xfrm>
-            <a:off x="822960" y="12591288"/>
+          <p:cNvPr id="15" name="Text 11"/>
+          <p:cNvSpPr/>
+          <p:nvPr/>
+        </p:nvSpPr>
+        <p:spPr>
+          <a:xfrm>
+            <a:off x="822960" y="13139928"/>
             <a:ext cx="6400800" cy="502920"/>
           </a:xfrm>
           <a:prstGeom prst="rect">
@@ -1376,41 +1353,18 @@
       </p:sp>
       <p:sp>
         <p:nvSpPr>
-          <p:cNvPr id="17" name="Shape 13"/>
-          <p:cNvSpPr/>
-          <p:nvPr/>
-        </p:nvSpPr>
-        <p:spPr>
-          <a:xfrm>
-            <a:off x="822960" y="13176504"/>
-            <a:ext cx="2011680" cy="0"/>
-          </a:xfrm>
-          <a:prstGeom prst="line">
-            <a:avLst/>
-          </a:prstGeom>
-          <a:noFill/>
-          <a:ln w="38100">
-            <a:solidFill>
-              <a:srgbClr val="C8102E"/>
-            </a:solidFill>
-            <a:prstDash val="solid"/>
-          </a:ln>
-        </p:spPr>
-      </p:sp>
-      <p:sp>
-        <p:nvSpPr>
-          <p:cNvPr id="18" name="Shape 14"/>
-          <p:cNvSpPr/>
-          <p:nvPr/>
-        </p:nvSpPr>
-        <p:spPr>
-          <a:xfrm>
-            <a:off x="822960" y="13341096"/>
-            <a:ext cx="6400800" cy="2560320"/>
+          <p:cNvPr id="16" name="Shape 12"/>
+          <p:cNvSpPr/>
+          <p:nvPr/>
+        </p:nvSpPr>
+        <p:spPr>
+          <a:xfrm>
+            <a:off x="822960" y="13889736"/>
+            <a:ext cx="6400800" cy="2926080"/>
           </a:xfrm>
           <a:prstGeom prst="roundRect">
             <a:avLst>
-              <a:gd name="adj" fmla="val 1786"/>
+              <a:gd name="adj" fmla="val 1563"/>
             </a:avLst>
           </a:prstGeom>
           <a:solidFill>
@@ -1426,14 +1380,14 @@
       </p:sp>
       <p:sp>
         <p:nvSpPr>
-          <p:cNvPr id="19" name="Text 15"/>
-          <p:cNvSpPr/>
-          <p:nvPr/>
-        </p:nvSpPr>
-        <p:spPr>
-          <a:xfrm>
-            <a:off x="1188720" y="13597128"/>
-            <a:ext cx="5669280" cy="2057400"/>
+          <p:cNvPr id="17" name="Text 13"/>
+          <p:cNvSpPr/>
+          <p:nvPr/>
+        </p:nvSpPr>
+        <p:spPr>
+          <a:xfrm>
+            <a:off x="1188720" y="14145768"/>
+            <a:ext cx="5669280" cy="2423160"/>
           </a:xfrm>
           <a:prstGeom prst="rect">
             <a:avLst/>
@@ -1468,13 +1422,13 @@
       </p:sp>
       <p:sp>
         <p:nvSpPr>
-          <p:cNvPr id="20" name="Text 16"/>
-          <p:cNvSpPr/>
-          <p:nvPr/>
-        </p:nvSpPr>
-        <p:spPr>
-          <a:xfrm>
-            <a:off x="822960" y="16450056"/>
+          <p:cNvPr id="18" name="Text 14"/>
+          <p:cNvSpPr/>
+          <p:nvPr/>
+        </p:nvSpPr>
+        <p:spPr>
+          <a:xfrm>
+            <a:off x="822960" y="17364456"/>
             <a:ext cx="6400800" cy="502920"/>
           </a:xfrm>
           <a:prstGeom prst="rect">
@@ -1507,37 +1461,14 @@
       </p:sp>
       <p:sp>
         <p:nvSpPr>
-          <p:cNvPr id="21" name="Shape 17"/>
-          <p:cNvSpPr/>
-          <p:nvPr/>
-        </p:nvSpPr>
-        <p:spPr>
-          <a:xfrm>
-            <a:off x="822960" y="17035272"/>
-            <a:ext cx="2011680" cy="0"/>
-          </a:xfrm>
-          <a:prstGeom prst="line">
-            <a:avLst/>
-          </a:prstGeom>
-          <a:noFill/>
-          <a:ln w="38100">
-            <a:solidFill>
-              <a:srgbClr val="C8102E"/>
-            </a:solidFill>
-            <a:prstDash val="solid"/>
-          </a:ln>
-        </p:spPr>
-      </p:sp>
-      <p:sp>
-        <p:nvSpPr>
-          <p:cNvPr id="22" name="Shape 18"/>
-          <p:cNvSpPr/>
-          <p:nvPr/>
-        </p:nvSpPr>
-        <p:spPr>
-          <a:xfrm>
-            <a:off x="822960" y="17199864"/>
-            <a:ext cx="6400800" cy="7863840"/>
+          <p:cNvPr id="19" name="Shape 15"/>
+          <p:cNvSpPr/>
+          <p:nvPr/>
+        </p:nvSpPr>
+        <p:spPr>
+          <a:xfrm>
+            <a:off x="822960" y="18114264"/>
+            <a:ext cx="6400800" cy="10058400"/>
           </a:xfrm>
           <a:prstGeom prst="roundRect">
             <a:avLst>
@@ -1557,14 +1488,14 @@
       </p:sp>
       <p:sp>
         <p:nvSpPr>
-          <p:cNvPr id="23" name="Text 19"/>
-          <p:cNvSpPr/>
-          <p:nvPr/>
-        </p:nvSpPr>
-        <p:spPr>
-          <a:xfrm>
-            <a:off x="1188720" y="17455896"/>
-            <a:ext cx="5669280" cy="7360920"/>
+          <p:cNvPr id="20" name="Text 16"/>
+          <p:cNvSpPr/>
+          <p:nvPr/>
+        </p:nvSpPr>
+        <p:spPr>
+          <a:xfrm>
+            <a:off x="1188720" y="18370296"/>
+            <a:ext cx="5669280" cy="9555480"/>
           </a:xfrm>
           <a:prstGeom prst="rect">
             <a:avLst/>
@@ -1663,7 +1594,7 @@
       </p:sp>
       <p:sp>
         <p:nvSpPr>
-          <p:cNvPr id="24" name="Text 20"/>
+          <p:cNvPr id="21" name="Text 17"/>
           <p:cNvSpPr/>
           <p:nvPr/>
         </p:nvSpPr>
@@ -1702,37 +1633,14 @@
       </p:sp>
       <p:sp>
         <p:nvSpPr>
-          <p:cNvPr id="25" name="Shape 21"/>
-          <p:cNvSpPr/>
-          <p:nvPr/>
-        </p:nvSpPr>
-        <p:spPr>
-          <a:xfrm>
-            <a:off x="7772400" y="7488936"/>
-            <a:ext cx="2011680" cy="0"/>
-          </a:xfrm>
-          <a:prstGeom prst="line">
-            <a:avLst/>
-          </a:prstGeom>
-          <a:noFill/>
-          <a:ln w="38100">
-            <a:solidFill>
-              <a:srgbClr val="C8102E"/>
-            </a:solidFill>
-            <a:prstDash val="solid"/>
-          </a:ln>
-        </p:spPr>
-      </p:sp>
-      <p:sp>
-        <p:nvSpPr>
-          <p:cNvPr id="26" name="Shape 22"/>
+          <p:cNvPr id="22" name="Shape 18"/>
           <p:cNvSpPr/>
           <p:nvPr/>
         </p:nvSpPr>
         <p:spPr>
           <a:xfrm>
             <a:off x="7772400" y="7653528"/>
-            <a:ext cx="6400800" cy="8961120"/>
+            <a:ext cx="6400800" cy="10058400"/>
           </a:xfrm>
           <a:prstGeom prst="roundRect">
             <a:avLst>
@@ -1752,14 +1660,14 @@
       </p:sp>
       <p:sp>
         <p:nvSpPr>
-          <p:cNvPr id="27" name="Text 23"/>
+          <p:cNvPr id="23" name="Text 19"/>
           <p:cNvSpPr/>
           <p:nvPr/>
         </p:nvSpPr>
         <p:spPr>
           <a:xfrm>
             <a:off x="8229600" y="7653528"/>
-            <a:ext cx="5486400" cy="8961120"/>
+            <a:ext cx="5486400" cy="10058400"/>
           </a:xfrm>
           <a:prstGeom prst="rect">
             <a:avLst/>
@@ -1863,18 +1771,18 @@
       </p:sp>
       <p:sp>
         <p:nvSpPr>
-          <p:cNvPr id="28" name="Shape 24"/>
-          <p:cNvSpPr/>
-          <p:nvPr/>
-        </p:nvSpPr>
-        <p:spPr>
-          <a:xfrm>
-            <a:off x="7772400" y="17071848"/>
-            <a:ext cx="6400800" cy="6035040"/>
+          <p:cNvPr id="24" name="Shape 20"/>
+          <p:cNvSpPr/>
+          <p:nvPr/>
+        </p:nvSpPr>
+        <p:spPr>
+          <a:xfrm>
+            <a:off x="7772400" y="18169128"/>
+            <a:ext cx="6400800" cy="6766560"/>
           </a:xfrm>
           <a:prstGeom prst="roundRect">
             <a:avLst>
-              <a:gd name="adj" fmla="val 758"/>
+              <a:gd name="adj" fmla="val 714"/>
             </a:avLst>
           </a:prstGeom>
           <a:solidFill>
@@ -1890,14 +1798,14 @@
       </p:sp>
       <p:sp>
         <p:nvSpPr>
-          <p:cNvPr id="29" name="Text 25"/>
-          <p:cNvSpPr/>
-          <p:nvPr/>
-        </p:nvSpPr>
-        <p:spPr>
-          <a:xfrm>
-            <a:off x="8229600" y="17071848"/>
-            <a:ext cx="5486400" cy="6035040"/>
+          <p:cNvPr id="25" name="Text 21"/>
+          <p:cNvSpPr/>
+          <p:nvPr/>
+        </p:nvSpPr>
+        <p:spPr>
+          <a:xfrm>
+            <a:off x="8229600" y="18169128"/>
+            <a:ext cx="5486400" cy="6766560"/>
           </a:xfrm>
           <a:prstGeom prst="rect">
             <a:avLst/>
@@ -1952,18 +1860,18 @@
       </p:sp>
       <p:sp>
         <p:nvSpPr>
-          <p:cNvPr id="30" name="Shape 26"/>
-          <p:cNvSpPr/>
-          <p:nvPr/>
-        </p:nvSpPr>
-        <p:spPr>
-          <a:xfrm>
-            <a:off x="7772400" y="23564088"/>
-            <a:ext cx="6400800" cy="2377440"/>
+          <p:cNvPr id="26" name="Shape 22"/>
+          <p:cNvSpPr/>
+          <p:nvPr/>
+        </p:nvSpPr>
+        <p:spPr>
+          <a:xfrm>
+            <a:off x="7772400" y="25392888"/>
+            <a:ext cx="6400800" cy="2560320"/>
           </a:xfrm>
           <a:prstGeom prst="roundRect">
             <a:avLst>
-              <a:gd name="adj" fmla="val 1923"/>
+              <a:gd name="adj" fmla="val 1786"/>
             </a:avLst>
           </a:prstGeom>
           <a:solidFill>
@@ -1979,13 +1887,13 @@
       </p:sp>
       <p:sp>
         <p:nvSpPr>
-          <p:cNvPr id="31" name="Text 27"/>
-          <p:cNvSpPr/>
-          <p:nvPr/>
-        </p:nvSpPr>
-        <p:spPr>
-          <a:xfrm>
-            <a:off x="8138160" y="23838408"/>
+          <p:cNvPr id="27" name="Text 23"/>
+          <p:cNvSpPr/>
+          <p:nvPr/>
+        </p:nvSpPr>
+        <p:spPr>
+          <a:xfrm>
+            <a:off x="8138160" y="25667208"/>
             <a:ext cx="5669280" cy="1828800"/>
           </a:xfrm>
           <a:prstGeom prst="rect">
@@ -2038,7 +1946,7 @@
       </p:sp>
       <p:sp>
         <p:nvSpPr>
-          <p:cNvPr id="32" name="Text 28"/>
+          <p:cNvPr id="28" name="Text 24"/>
           <p:cNvSpPr/>
           <p:nvPr/>
         </p:nvSpPr>
@@ -2077,37 +1985,14 @@
       </p:sp>
       <p:sp>
         <p:nvSpPr>
-          <p:cNvPr id="33" name="Shape 29"/>
-          <p:cNvSpPr/>
-          <p:nvPr/>
-        </p:nvSpPr>
-        <p:spPr>
-          <a:xfrm>
-            <a:off x="14721840" y="7488936"/>
-            <a:ext cx="2011680" cy="0"/>
-          </a:xfrm>
-          <a:prstGeom prst="line">
-            <a:avLst/>
-          </a:prstGeom>
-          <a:noFill/>
-          <a:ln w="38100">
-            <a:solidFill>
-              <a:srgbClr val="C8102E"/>
-            </a:solidFill>
-            <a:prstDash val="solid"/>
-          </a:ln>
-        </p:spPr>
-      </p:sp>
-      <p:sp>
-        <p:nvSpPr>
-          <p:cNvPr id="34" name="Shape 30"/>
+          <p:cNvPr id="29" name="Shape 25"/>
           <p:cNvSpPr/>
           <p:nvPr/>
         </p:nvSpPr>
         <p:spPr>
           <a:xfrm>
             <a:off x="14721840" y="7653528"/>
-            <a:ext cx="6400800" cy="6400800"/>
+            <a:ext cx="6400800" cy="8046720"/>
           </a:xfrm>
           <a:prstGeom prst="roundRect">
             <a:avLst>
@@ -2127,14 +2012,14 @@
       </p:sp>
       <p:sp>
         <p:nvSpPr>
-          <p:cNvPr id="35" name="Text 31"/>
+          <p:cNvPr id="30" name="Text 26"/>
           <p:cNvSpPr/>
           <p:nvPr/>
         </p:nvSpPr>
         <p:spPr>
           <a:xfrm>
             <a:off x="15087600" y="7909560"/>
-            <a:ext cx="5669280" cy="5897880"/>
+            <a:ext cx="5669280" cy="7543800"/>
           </a:xfrm>
           <a:prstGeom prst="rect">
             <a:avLst/>
@@ -2169,13 +2054,13 @@
       </p:sp>
       <p:sp>
         <p:nvSpPr>
-          <p:cNvPr id="36" name="Text 32"/>
-          <p:cNvSpPr/>
-          <p:nvPr/>
-        </p:nvSpPr>
-        <p:spPr>
-          <a:xfrm>
-            <a:off x="14721840" y="14602968"/>
+          <p:cNvPr id="31" name="Text 27"/>
+          <p:cNvSpPr/>
+          <p:nvPr/>
+        </p:nvSpPr>
+        <p:spPr>
+          <a:xfrm>
+            <a:off x="14721840" y="16248888"/>
             <a:ext cx="6400800" cy="502920"/>
           </a:xfrm>
           <a:prstGeom prst="rect">
@@ -2208,41 +2093,18 @@
       </p:sp>
       <p:sp>
         <p:nvSpPr>
-          <p:cNvPr id="37" name="Shape 33"/>
-          <p:cNvSpPr/>
-          <p:nvPr/>
-        </p:nvSpPr>
-        <p:spPr>
-          <a:xfrm>
-            <a:off x="14721840" y="15188184"/>
-            <a:ext cx="2011680" cy="0"/>
-          </a:xfrm>
-          <a:prstGeom prst="line">
-            <a:avLst/>
-          </a:prstGeom>
-          <a:noFill/>
-          <a:ln w="38100">
-            <a:solidFill>
-              <a:srgbClr val="C8102E"/>
-            </a:solidFill>
-            <a:prstDash val="solid"/>
-          </a:ln>
-        </p:spPr>
-      </p:sp>
-      <p:sp>
-        <p:nvSpPr>
-          <p:cNvPr id="38" name="Shape 34"/>
-          <p:cNvSpPr/>
-          <p:nvPr/>
-        </p:nvSpPr>
-        <p:spPr>
-          <a:xfrm>
-            <a:off x="14721840" y="15352776"/>
-            <a:ext cx="6400800" cy="4023360"/>
+          <p:cNvPr id="32" name="Shape 28"/>
+          <p:cNvSpPr/>
+          <p:nvPr/>
+        </p:nvSpPr>
+        <p:spPr>
+          <a:xfrm>
+            <a:off x="14721840" y="16998696"/>
+            <a:ext cx="6400800" cy="4389120"/>
           </a:xfrm>
           <a:prstGeom prst="roundRect">
             <a:avLst>
-              <a:gd name="adj" fmla="val 1136"/>
+              <a:gd name="adj" fmla="val 1042"/>
             </a:avLst>
           </a:prstGeom>
           <a:solidFill>
@@ -2258,14 +2120,14 @@
       </p:sp>
       <p:sp>
         <p:nvSpPr>
-          <p:cNvPr id="39" name="Text 35"/>
-          <p:cNvSpPr/>
-          <p:nvPr/>
-        </p:nvSpPr>
-        <p:spPr>
-          <a:xfrm>
-            <a:off x="15087600" y="15608808"/>
-            <a:ext cx="5669280" cy="3520440"/>
+          <p:cNvPr id="33" name="Text 29"/>
+          <p:cNvSpPr/>
+          <p:nvPr/>
+        </p:nvSpPr>
+        <p:spPr>
+          <a:xfrm>
+            <a:off x="15087600" y="17254728"/>
+            <a:ext cx="5669280" cy="3886200"/>
           </a:xfrm>
           <a:prstGeom prst="rect">
             <a:avLst/>
@@ -2300,13 +2162,13 @@
       </p:sp>
       <p:sp>
         <p:nvSpPr>
-          <p:cNvPr id="40" name="Text 36"/>
-          <p:cNvSpPr/>
-          <p:nvPr/>
-        </p:nvSpPr>
-        <p:spPr>
-          <a:xfrm>
-            <a:off x="14721840" y="19924776"/>
+          <p:cNvPr id="34" name="Text 30"/>
+          <p:cNvSpPr/>
+          <p:nvPr/>
+        </p:nvSpPr>
+        <p:spPr>
+          <a:xfrm>
+            <a:off x="14721840" y="21936456"/>
             <a:ext cx="6400800" cy="502920"/>
           </a:xfrm>
           <a:prstGeom prst="rect">
@@ -2339,41 +2201,18 @@
       </p:sp>
       <p:sp>
         <p:nvSpPr>
-          <p:cNvPr id="41" name="Shape 37"/>
-          <p:cNvSpPr/>
-          <p:nvPr/>
-        </p:nvSpPr>
-        <p:spPr>
-          <a:xfrm>
-            <a:off x="14721840" y="20509992"/>
-            <a:ext cx="2011680" cy="0"/>
-          </a:xfrm>
-          <a:prstGeom prst="line">
-            <a:avLst/>
-          </a:prstGeom>
-          <a:noFill/>
-          <a:ln w="38100">
-            <a:solidFill>
-              <a:srgbClr val="C8102E"/>
-            </a:solidFill>
-            <a:prstDash val="solid"/>
-          </a:ln>
-        </p:spPr>
-      </p:sp>
-      <p:sp>
-        <p:nvSpPr>
-          <p:cNvPr id="42" name="Shape 38"/>
-          <p:cNvSpPr/>
-          <p:nvPr/>
-        </p:nvSpPr>
-        <p:spPr>
-          <a:xfrm>
-            <a:off x="14721840" y="20674584"/>
-            <a:ext cx="6400800" cy="3840480"/>
+          <p:cNvPr id="35" name="Shape 31"/>
+          <p:cNvSpPr/>
+          <p:nvPr/>
+        </p:nvSpPr>
+        <p:spPr>
+          <a:xfrm>
+            <a:off x="14721840" y="22686264"/>
+            <a:ext cx="6400800" cy="4754880"/>
           </a:xfrm>
           <a:prstGeom prst="roundRect">
             <a:avLst>
-              <a:gd name="adj" fmla="val 1190"/>
+              <a:gd name="adj" fmla="val 962"/>
             </a:avLst>
           </a:prstGeom>
           <a:solidFill>
@@ -2389,14 +2228,14 @@
       </p:sp>
       <p:sp>
         <p:nvSpPr>
-          <p:cNvPr id="43" name="Text 39"/>
-          <p:cNvSpPr/>
-          <p:nvPr/>
-        </p:nvSpPr>
-        <p:spPr>
-          <a:xfrm>
-            <a:off x="15087600" y="20930616"/>
-            <a:ext cx="5669280" cy="3337560"/>
+          <p:cNvPr id="36" name="Text 32"/>
+          <p:cNvSpPr/>
+          <p:nvPr/>
+        </p:nvSpPr>
+        <p:spPr>
+          <a:xfrm>
+            <a:off x="15087600" y="22942296"/>
+            <a:ext cx="5669280" cy="4251960"/>
           </a:xfrm>
           <a:prstGeom prst="rect">
             <a:avLst/>
@@ -2431,7 +2270,7 @@
       </p:sp>
       <p:sp>
         <p:nvSpPr>
-          <p:cNvPr id="44" name="Shape 40"/>
+          <p:cNvPr id="37" name="Shape 33"/>
           <p:cNvSpPr/>
           <p:nvPr/>
         </p:nvSpPr>
@@ -2451,7 +2290,7 @@
       </p:sp>
       <p:pic>
         <p:nvPicPr>
-          <p:cNvPr id="45" name="Image 2" descr="/Users/heidiandersen/ntog/ntog-logo-1024.png">    </p:cNvPr>
+          <p:cNvPr id="38" name="Image 2" descr="/Users/heidiandersen/ntog/ntog-logo-1024.png">    </p:cNvPr>
           <p:cNvPicPr>
             <a:picLocks noChangeAspect="1"/>
           </p:cNvPicPr>
@@ -2475,7 +2314,7 @@
       </p:pic>
       <p:sp>
         <p:nvSpPr>
-          <p:cNvPr id="46" name="Text 41"/>
+          <p:cNvPr id="39" name="Text 34"/>
           <p:cNvSpPr/>
           <p:nvPr/>
         </p:nvSpPr>

</xml_diff>